<commit_message>
added video in readme
</commit_message>
<xml_diff>
--- a/docs/StudyNotes+-Pitch-Deck.pptx
+++ b/docs/StudyNotes+-Pitch-Deck.pptx
@@ -1,24 +1,24 @@
 
 <file path=ppt/presentation.xml><?xml version="1.0" encoding="utf-8"?>
-<p:presentation xmlns:a="http://schemas.openxmlformats.org/drawingml/2006/main" xmlns:r="http://schemas.openxmlformats.org/officeDocument/2006/relationships" xmlns:p="http://schemas.openxmlformats.org/presentationml/2006/main" saveSubsetFonts="1" autoCompressPictures="0">
+<p:presentation xmlns:a="http://schemas.openxmlformats.org/drawingml/2006/main" xmlns:r="http://schemas.openxmlformats.org/officeDocument/2006/relationships" xmlns:p="http://schemas.openxmlformats.org/presentationml/2006/main" autoCompressPictures="0">
   <p:sldMasterIdLst>
     <p:sldMasterId id="2147483648" r:id="rId1"/>
   </p:sldMasterIdLst>
+  <p:notesMasterIdLst>
+    <p:notesMasterId r:id="rId4"/>
+  </p:notesMasterIdLst>
   <p:sldIdLst>
-    <p:sldId id="256" r:id="rId2"/>
-    <p:sldId id="257" r:id="rId3"/>
-    <p:sldId id="258" r:id="rId4"/>
-    <p:sldId id="259" r:id="rId5"/>
-    <p:sldId id="260" r:id="rId6"/>
-    <p:sldId id="261" r:id="rId7"/>
-    <p:sldId id="262" r:id="rId8"/>
-    <p:sldId id="263" r:id="rId9"/>
+    <p:sldId id="256" r:id="rId3"/>
+    <p:sldId id="257" r:id="rId5"/>
+    <p:sldId id="258" r:id="rId6"/>
+    <p:sldId id="259" r:id="rId7"/>
+    <p:sldId id="260" r:id="rId8"/>
+    <p:sldId id="261" r:id="rId9"/>
+    <p:sldId id="262" r:id="rId10"/>
+    <p:sldId id="263" r:id="rId11"/>
   </p:sldIdLst>
-  <p:notesMasterIdLst>
-    <p:notesMasterId r:id="rId10"/>
-  </p:notesMasterIdLst>
-  <p:sldSz cx="12191695" cy="6858000"/>
-  <p:notesSz cx="6858000" cy="12191695"/>
+  <p:sldSz cx="12191365" cy="6858000"/>
+  <p:notesSz cx="6858000" cy="12191365"/>
   <p:defaultTextStyle>
     <a:lvl1pPr marL="0" algn="l" defTabSz="914400" rtl="0" eaLnBrk="1" latinLnBrk="0" hangingPunct="1">
       <a:defRPr sz="1800" kern="1200">
@@ -196,7 +196,6 @@
           <a:p>
             <a:fld id="{5282F153-3F37-0F45-9E97-73ACFA13230C}" type="datetimeFigureOut">
               <a:rPr lang="en-US"/>
-              <a:t>7/23/19</a:t>
             </a:fld>
             <a:endParaRPr lang="en-US"/>
           </a:p>
@@ -263,6 +262,7 @@
               <a:rPr lang="en-US"/>
               <a:t>Click to edit Master text styles</a:t>
             </a:r>
+            <a:endParaRPr lang="en-US"/>
           </a:p>
           <a:p>
             <a:pPr lvl="1"/>
@@ -270,6 +270,7 @@
               <a:rPr lang="en-US"/>
               <a:t>Second level</a:t>
             </a:r>
+            <a:endParaRPr lang="en-US"/>
           </a:p>
           <a:p>
             <a:pPr lvl="2"/>
@@ -277,6 +278,7 @@
               <a:rPr lang="en-US"/>
               <a:t>Third level</a:t>
             </a:r>
+            <a:endParaRPr lang="en-US"/>
           </a:p>
           <a:p>
             <a:pPr lvl="3"/>
@@ -284,6 +286,7 @@
               <a:rPr lang="en-US"/>
               <a:t>Fourth level</a:t>
             </a:r>
+            <a:endParaRPr lang="en-US"/>
           </a:p>
           <a:p>
             <a:pPr lvl="4"/>
@@ -291,6 +294,7 @@
               <a:rPr lang="en-US"/>
               <a:t>Fifth level</a:t>
             </a:r>
+            <a:endParaRPr lang="en-US"/>
           </a:p>
         </p:txBody>
       </p:sp>
@@ -354,18 +358,12 @@
           <a:p>
             <a:fld id="{CE5E9CC1-C706-0F49-92D6-E571CC5EEA8F}" type="slidenum">
               <a:rPr lang="en-US"/>
-              <a:t>‹#›</a:t>
             </a:fld>
             <a:endParaRPr lang="en-US"/>
           </a:p>
         </p:txBody>
       </p:sp>
     </p:spTree>
-    <p:extLst>
-      <p:ext uri="{BB962C8B-B14F-4D97-AF65-F5344CB8AC3E}">
-        <p14:creationId xmlns:p14="http://schemas.microsoft.com/office/powerpoint/2010/main" val="1024086991"/>
-      </p:ext>
-    </p:extLst>
   </p:cSld>
   <p:clrMap bg1="lt1" tx1="dk1" bg2="lt2" tx2="dk2" accent1="accent1" accent2="accent2" accent3="accent3" accent4="accent4" accent5="accent5" accent6="accent6" hlink="hlink" folHlink="folHlink"/>
   <p:notesStyle>
@@ -507,10 +505,6 @@
           <a:bodyPr/>
           <a:lstStyle/>
           <a:p>
-            <a:r>
-              <a:rPr lang="en-US" dirty="0"/>
-              <a:t/>
-            </a:r>
             <a:endParaRPr lang="en-US" dirty="0"/>
           </a:p>
         </p:txBody>
@@ -532,18 +526,12 @@
           <a:p>
             <a:fld id="{F7021451-1387-4CA6-816F-3879F97B5CBC}" type="slidenum">
               <a:rPr lang="en-US"/>
-              <a:t>1</a:t>
             </a:fld>
             <a:endParaRPr lang="en-US"/>
           </a:p>
         </p:txBody>
       </p:sp>
     </p:spTree>
-    <p:extLst>
-      <p:ext uri="{BB962C8B-B14F-4D97-AF65-F5344CB8AC3E}">
-        <p14:creationId xmlns:p14="http://schemas.microsoft.com/office/powerpoint/2010/main" val="1024086991"/>
-      </p:ext>
-    </p:extLst>
   </p:cSld>
   <p:clrMapOvr>
     <a:masterClrMapping/>
@@ -595,10 +583,6 @@
           <a:bodyPr/>
           <a:lstStyle/>
           <a:p>
-            <a:r>
-              <a:rPr lang="en-US" dirty="0"/>
-              <a:t/>
-            </a:r>
             <a:endParaRPr lang="en-US" dirty="0"/>
           </a:p>
         </p:txBody>
@@ -620,18 +604,12 @@
           <a:p>
             <a:fld id="{F7021451-1387-4CA6-816F-3879F97B5CBC}" type="slidenum">
               <a:rPr lang="en-US"/>
-              <a:t>2</a:t>
             </a:fld>
             <a:endParaRPr lang="en-US"/>
           </a:p>
         </p:txBody>
       </p:sp>
     </p:spTree>
-    <p:extLst>
-      <p:ext uri="{BB962C8B-B14F-4D97-AF65-F5344CB8AC3E}">
-        <p14:creationId xmlns:p14="http://schemas.microsoft.com/office/powerpoint/2010/main" val="1024086991"/>
-      </p:ext>
-    </p:extLst>
   </p:cSld>
   <p:clrMapOvr>
     <a:masterClrMapping/>
@@ -683,10 +661,6 @@
           <a:bodyPr/>
           <a:lstStyle/>
           <a:p>
-            <a:r>
-              <a:rPr lang="en-US" dirty="0"/>
-              <a:t/>
-            </a:r>
             <a:endParaRPr lang="en-US" dirty="0"/>
           </a:p>
         </p:txBody>
@@ -708,18 +682,12 @@
           <a:p>
             <a:fld id="{F7021451-1387-4CA6-816F-3879F97B5CBC}" type="slidenum">
               <a:rPr lang="en-US"/>
-              <a:t>3</a:t>
             </a:fld>
             <a:endParaRPr lang="en-US"/>
           </a:p>
         </p:txBody>
       </p:sp>
     </p:spTree>
-    <p:extLst>
-      <p:ext uri="{BB962C8B-B14F-4D97-AF65-F5344CB8AC3E}">
-        <p14:creationId xmlns:p14="http://schemas.microsoft.com/office/powerpoint/2010/main" val="1024086991"/>
-      </p:ext>
-    </p:extLst>
   </p:cSld>
   <p:clrMapOvr>
     <a:masterClrMapping/>
@@ -771,10 +739,6 @@
           <a:bodyPr/>
           <a:lstStyle/>
           <a:p>
-            <a:r>
-              <a:rPr lang="en-US" dirty="0"/>
-              <a:t/>
-            </a:r>
             <a:endParaRPr lang="en-US" dirty="0"/>
           </a:p>
         </p:txBody>
@@ -796,18 +760,12 @@
           <a:p>
             <a:fld id="{F7021451-1387-4CA6-816F-3879F97B5CBC}" type="slidenum">
               <a:rPr lang="en-US"/>
-              <a:t>4</a:t>
             </a:fld>
             <a:endParaRPr lang="en-US"/>
           </a:p>
         </p:txBody>
       </p:sp>
     </p:spTree>
-    <p:extLst>
-      <p:ext uri="{BB962C8B-B14F-4D97-AF65-F5344CB8AC3E}">
-        <p14:creationId xmlns:p14="http://schemas.microsoft.com/office/powerpoint/2010/main" val="1024086991"/>
-      </p:ext>
-    </p:extLst>
   </p:cSld>
   <p:clrMapOvr>
     <a:masterClrMapping/>
@@ -859,10 +817,6 @@
           <a:bodyPr/>
           <a:lstStyle/>
           <a:p>
-            <a:r>
-              <a:rPr lang="en-US" dirty="0"/>
-              <a:t/>
-            </a:r>
             <a:endParaRPr lang="en-US" dirty="0"/>
           </a:p>
         </p:txBody>
@@ -884,18 +838,12 @@
           <a:p>
             <a:fld id="{F7021451-1387-4CA6-816F-3879F97B5CBC}" type="slidenum">
               <a:rPr lang="en-US"/>
-              <a:t>5</a:t>
             </a:fld>
             <a:endParaRPr lang="en-US"/>
           </a:p>
         </p:txBody>
       </p:sp>
     </p:spTree>
-    <p:extLst>
-      <p:ext uri="{BB962C8B-B14F-4D97-AF65-F5344CB8AC3E}">
-        <p14:creationId xmlns:p14="http://schemas.microsoft.com/office/powerpoint/2010/main" val="1024086991"/>
-      </p:ext>
-    </p:extLst>
   </p:cSld>
   <p:clrMapOvr>
     <a:masterClrMapping/>
@@ -947,10 +895,6 @@
           <a:bodyPr/>
           <a:lstStyle/>
           <a:p>
-            <a:r>
-              <a:rPr lang="en-US" dirty="0"/>
-              <a:t/>
-            </a:r>
             <a:endParaRPr lang="en-US" dirty="0"/>
           </a:p>
         </p:txBody>
@@ -972,18 +916,12 @@
           <a:p>
             <a:fld id="{F7021451-1387-4CA6-816F-3879F97B5CBC}" type="slidenum">
               <a:rPr lang="en-US"/>
-              <a:t>6</a:t>
             </a:fld>
             <a:endParaRPr lang="en-US"/>
           </a:p>
         </p:txBody>
       </p:sp>
     </p:spTree>
-    <p:extLst>
-      <p:ext uri="{BB962C8B-B14F-4D97-AF65-F5344CB8AC3E}">
-        <p14:creationId xmlns:p14="http://schemas.microsoft.com/office/powerpoint/2010/main" val="1024086991"/>
-      </p:ext>
-    </p:extLst>
   </p:cSld>
   <p:clrMapOvr>
     <a:masterClrMapping/>
@@ -1035,10 +973,6 @@
           <a:bodyPr/>
           <a:lstStyle/>
           <a:p>
-            <a:r>
-              <a:rPr lang="en-US" dirty="0"/>
-              <a:t/>
-            </a:r>
             <a:endParaRPr lang="en-US" dirty="0"/>
           </a:p>
         </p:txBody>
@@ -1060,18 +994,12 @@
           <a:p>
             <a:fld id="{F7021451-1387-4CA6-816F-3879F97B5CBC}" type="slidenum">
               <a:rPr lang="en-US"/>
-              <a:t>7</a:t>
             </a:fld>
             <a:endParaRPr lang="en-US"/>
           </a:p>
         </p:txBody>
       </p:sp>
     </p:spTree>
-    <p:extLst>
-      <p:ext uri="{BB962C8B-B14F-4D97-AF65-F5344CB8AC3E}">
-        <p14:creationId xmlns:p14="http://schemas.microsoft.com/office/powerpoint/2010/main" val="1024086991"/>
-      </p:ext>
-    </p:extLst>
   </p:cSld>
   <p:clrMapOvr>
     <a:masterClrMapping/>
@@ -1123,10 +1051,6 @@
           <a:bodyPr/>
           <a:lstStyle/>
           <a:p>
-            <a:r>
-              <a:rPr lang="en-US" dirty="0"/>
-              <a:t/>
-            </a:r>
             <a:endParaRPr lang="en-US" dirty="0"/>
           </a:p>
         </p:txBody>
@@ -1148,18 +1072,12 @@
           <a:p>
             <a:fld id="{F7021451-1387-4CA6-816F-3879F97B5CBC}" type="slidenum">
               <a:rPr lang="en-US"/>
-              <a:t>8</a:t>
             </a:fld>
             <a:endParaRPr lang="en-US"/>
           </a:p>
         </p:txBody>
       </p:sp>
     </p:spTree>
-    <p:extLst>
-      <p:ext uri="{BB962C8B-B14F-4D97-AF65-F5344CB8AC3E}">
-        <p14:creationId xmlns:p14="http://schemas.microsoft.com/office/powerpoint/2010/main" val="1024086991"/>
-      </p:ext>
-    </p:extLst>
   </p:cSld>
   <p:clrMapOvr>
     <a:masterClrMapping/>
@@ -1200,6 +1118,11 @@
 <file path=ppt/slideMasters/slideMaster1.xml><?xml version="1.0" encoding="utf-8"?>
 <p:sldMaster xmlns:a="http://schemas.openxmlformats.org/drawingml/2006/main" xmlns:r="http://schemas.openxmlformats.org/officeDocument/2006/relationships" xmlns:p="http://schemas.openxmlformats.org/presentationml/2006/main">
   <p:cSld>
+    <p:bg>
+      <p:bgRef idx="1001">
+        <a:schemeClr val="bg1"/>
+      </p:bgRef>
+    </p:bg>
     <p:spTree>
       <p:nvGrpSpPr>
         <p:cNvPr id="1" name=""/>
@@ -1243,7 +1166,7 @@
         <a:spcBef>
           <a:spcPct val="20000"/>
         </a:spcBef>
-        <a:buFont typeface="Arial" pitchFamily="34" charset="0"/>
+        <a:buFont typeface="Arial" panose="020B0604020202020204" pitchFamily="34" charset="0"/>
         <a:buChar char="•"/>
         <a:defRPr sz="3200" kern="1200">
           <a:solidFill>
@@ -1258,7 +1181,7 @@
         <a:spcBef>
           <a:spcPct val="20000"/>
         </a:spcBef>
-        <a:buFont typeface="Arial" pitchFamily="34" charset="0"/>
+        <a:buFont typeface="Arial" panose="020B0604020202020204" pitchFamily="34" charset="0"/>
         <a:buChar char="–"/>
         <a:defRPr sz="2800" kern="1200">
           <a:solidFill>
@@ -1273,7 +1196,7 @@
         <a:spcBef>
           <a:spcPct val="20000"/>
         </a:spcBef>
-        <a:buFont typeface="Arial" pitchFamily="34" charset="0"/>
+        <a:buFont typeface="Arial" panose="020B0604020202020204" pitchFamily="34" charset="0"/>
         <a:buChar char="•"/>
         <a:defRPr sz="2400" kern="1200">
           <a:solidFill>
@@ -1288,7 +1211,7 @@
         <a:spcBef>
           <a:spcPct val="20000"/>
         </a:spcBef>
-        <a:buFont typeface="Arial" pitchFamily="34" charset="0"/>
+        <a:buFont typeface="Arial" panose="020B0604020202020204" pitchFamily="34" charset="0"/>
         <a:buChar char="–"/>
         <a:defRPr sz="2000" kern="1200">
           <a:solidFill>
@@ -1303,7 +1226,7 @@
         <a:spcBef>
           <a:spcPct val="20000"/>
         </a:spcBef>
-        <a:buFont typeface="Arial" pitchFamily="34" charset="0"/>
+        <a:buFont typeface="Arial" panose="020B0604020202020204" pitchFamily="34" charset="0"/>
         <a:buChar char="»"/>
         <a:defRPr sz="2000" kern="1200">
           <a:solidFill>
@@ -1318,7 +1241,7 @@
         <a:spcBef>
           <a:spcPct val="20000"/>
         </a:spcBef>
-        <a:buFont typeface="Arial" pitchFamily="34" charset="0"/>
+        <a:buFont typeface="Arial" panose="020B0604020202020204" pitchFamily="34" charset="0"/>
         <a:buChar char="•"/>
         <a:defRPr sz="2000" kern="1200">
           <a:solidFill>
@@ -1333,7 +1256,7 @@
         <a:spcBef>
           <a:spcPct val="20000"/>
         </a:spcBef>
-        <a:buFont typeface="Arial" pitchFamily="34" charset="0"/>
+        <a:buFont typeface="Arial" panose="020B0604020202020204" pitchFamily="34" charset="0"/>
         <a:buChar char="•"/>
         <a:defRPr sz="2000" kern="1200">
           <a:solidFill>
@@ -1348,7 +1271,7 @@
         <a:spcBef>
           <a:spcPct val="20000"/>
         </a:spcBef>
-        <a:buFont typeface="Arial" pitchFamily="34" charset="0"/>
+        <a:buFont typeface="Arial" panose="020B0604020202020204" pitchFamily="34" charset="0"/>
         <a:buChar char="•"/>
         <a:defRPr sz="2000" kern="1200">
           <a:solidFill>
@@ -1363,7 +1286,7 @@
         <a:spcBef>
           <a:spcPct val="20000"/>
         </a:spcBef>
-        <a:buFont typeface="Arial" pitchFamily="34" charset="0"/>
+        <a:buFont typeface="Arial" panose="020B0604020202020204" pitchFamily="34" charset="0"/>
         <a:buChar char="•"/>
         <a:defRPr sz="2000" kern="1200">
           <a:solidFill>
@@ -1476,12 +1399,13 @@
 
 <file path=ppt/slides/slide1.xml><?xml version="1.0" encoding="utf-8"?>
 <p:sld xmlns:a="http://schemas.openxmlformats.org/drawingml/2006/main" xmlns:r="http://schemas.openxmlformats.org/officeDocument/2006/relationships" xmlns:p="http://schemas.openxmlformats.org/presentationml/2006/main">
-  <p:cSld name="Slide 1">
+  <p:cSld>
     <p:bg>
       <p:bgPr>
         <a:solidFill>
           <a:srgbClr val="0B1020"/>
         </a:solidFill>
+        <a:effectLst/>
       </p:bgPr>
     </p:bg>
     <p:spTree>
@@ -1517,7 +1441,6 @@
               <a:alpha val="18000"/>
             </a:srgbClr>
           </a:solidFill>
-          <a:ln/>
         </p:spPr>
       </p:sp>
       <p:sp>
@@ -1539,7 +1462,6 @@
               <a:alpha val="12000"/>
             </a:srgbClr>
           </a:solidFill>
-          <a:ln/>
         </p:spPr>
       </p:sp>
       <p:sp>
@@ -1561,7 +1483,6 @@
               <a:alpha val="10000"/>
             </a:srgbClr>
           </a:solidFill>
-          <a:ln/>
         </p:spPr>
       </p:sp>
       <p:sp>
@@ -1583,7 +1504,6 @@
           <a:solidFill>
             <a:srgbClr val="6366F1"/>
           </a:solidFill>
-          <a:ln/>
         </p:spPr>
       </p:sp>
       <p:sp>
@@ -1601,23 +1521,22 @@
             <a:avLst/>
           </a:prstGeom>
           <a:noFill/>
-          <a:ln/>
         </p:spPr>
         <p:txBody>
           <a:bodyPr wrap="square" rtlCol="0" anchor="ctr"/>
           <a:lstStyle/>
           <a:p>
-            <a:pPr algn="ctr" indent="0" marL="0">
-              <a:buNone/>
-            </a:pPr>
-            <a:r>
-              <a:rPr lang="en-US" sz="1200" b="1" spc="100" kern="0" dirty="0">
+            <a:pPr marL="0" indent="0" algn="ctr">
+              <a:buNone/>
+            </a:pPr>
+            <a:r>
+              <a:rPr lang="en-US" sz="1200" b="1" kern="0" spc="100" dirty="0">
                 <a:solidFill>
                   <a:srgbClr val="FFFFFF"/>
                 </a:solidFill>
-                <a:latin typeface="Arial" pitchFamily="34" charset="0"/>
-                <a:ea typeface="Arial" pitchFamily="34" charset="-122"/>
-                <a:cs typeface="Arial" pitchFamily="34" charset="-120"/>
+                <a:latin typeface="Arial" panose="020B0604020202020204" pitchFamily="34" charset="0"/>
+                <a:ea typeface="Arial" panose="020B0604020202020204" pitchFamily="34" charset="-122"/>
+                <a:cs typeface="Arial" panose="020B0604020202020204" pitchFamily="34" charset="-120"/>
               </a:rPr>
               <a:t>AI STUDY COMPANION</a:t>
             </a:r>
@@ -1640,13 +1559,12 @@
             <a:avLst/>
           </a:prstGeom>
           <a:noFill/>
-          <a:ln/>
         </p:spPr>
         <p:txBody>
           <a:bodyPr wrap="square" rtlCol="0" anchor="ctr"/>
           <a:lstStyle/>
           <a:p>
-            <a:pPr indent="0" marL="0">
+            <a:pPr marL="0" indent="0">
               <a:buNone/>
             </a:pPr>
             <a:r>
@@ -1654,9 +1572,9 @@
                 <a:solidFill>
                   <a:srgbClr val="F8FAFC"/>
                 </a:solidFill>
-                <a:latin typeface="Arial" pitchFamily="34" charset="0"/>
-                <a:ea typeface="Arial" pitchFamily="34" charset="-122"/>
-                <a:cs typeface="Arial" pitchFamily="34" charset="-120"/>
+                <a:latin typeface="Arial" panose="020B0604020202020204" pitchFamily="34" charset="0"/>
+                <a:ea typeface="Arial" panose="020B0604020202020204" pitchFamily="34" charset="-122"/>
+                <a:cs typeface="Arial" panose="020B0604020202020204" pitchFamily="34" charset="-120"/>
               </a:rPr>
               <a:t>StudyNotes+</a:t>
             </a:r>
@@ -1672,7 +1590,7 @@
         </p:nvSpPr>
         <p:spPr>
           <a:xfrm>
-            <a:off x="822960" y="3063240"/>
+            <a:off x="822960" y="2994660"/>
             <a:ext cx="1371600" cy="411480"/>
           </a:xfrm>
           <a:prstGeom prst="roundRect">
@@ -1683,7 +1601,6 @@
           <a:solidFill>
             <a:srgbClr val="2DD4BF"/>
           </a:solidFill>
-          <a:ln/>
         </p:spPr>
       </p:sp>
       <p:sp>
@@ -1694,30 +1611,29 @@
         </p:nvSpPr>
         <p:spPr>
           <a:xfrm>
-            <a:off x="822960" y="3063240"/>
+            <a:off x="822960" y="3017520"/>
             <a:ext cx="1371600" cy="411480"/>
           </a:xfrm>
           <a:prstGeom prst="rect">
             <a:avLst/>
           </a:prstGeom>
           <a:noFill/>
-          <a:ln/>
         </p:spPr>
         <p:txBody>
           <a:bodyPr wrap="square" rtlCol="0" anchor="ctr"/>
           <a:lstStyle/>
           <a:p>
-            <a:pPr algn="ctr" indent="0" marL="0">
-              <a:buNone/>
-            </a:pPr>
-            <a:r>
-              <a:rPr lang="en-US" sz="1300" b="1" spc="100" kern="0" dirty="0">
+            <a:pPr marL="0" indent="0" algn="ctr">
+              <a:buNone/>
+            </a:pPr>
+            <a:r>
+              <a:rPr lang="en-US" sz="1300" b="1" kern="0" spc="100" dirty="0">
                 <a:solidFill>
                   <a:srgbClr val="06231F"/>
                 </a:solidFill>
-                <a:latin typeface="Arial" pitchFamily="34" charset="0"/>
-                <a:ea typeface="Arial" pitchFamily="34" charset="-122"/>
-                <a:cs typeface="Arial" pitchFamily="34" charset="-120"/>
+                <a:latin typeface="Arial" panose="020B0604020202020204" pitchFamily="34" charset="0"/>
+                <a:ea typeface="Arial" panose="020B0604020202020204" pitchFamily="34" charset="-122"/>
+                <a:cs typeface="Arial" panose="020B0604020202020204" pitchFamily="34" charset="-120"/>
               </a:rPr>
               <a:t>MVP</a:t>
             </a:r>
@@ -1744,7 +1660,6 @@
           <a:solidFill>
             <a:srgbClr val="F59E0B"/>
           </a:solidFill>
-          <a:ln/>
         </p:spPr>
       </p:sp>
       <p:sp>
@@ -1762,13 +1677,12 @@
             <a:avLst/>
           </a:prstGeom>
           <a:noFill/>
-          <a:ln/>
         </p:spPr>
         <p:txBody>
           <a:bodyPr wrap="square" rtlCol="0" anchor="ctr"/>
           <a:lstStyle/>
           <a:p>
-            <a:pPr indent="0" marL="0">
+            <a:pPr marL="0" indent="0">
               <a:buNone/>
             </a:pPr>
             <a:r>
@@ -1776,9 +1690,9 @@
                 <a:solidFill>
                   <a:srgbClr val="818CF8"/>
                 </a:solidFill>
-                <a:latin typeface="Arial" pitchFamily="34" charset="0"/>
-                <a:ea typeface="Arial" pitchFamily="34" charset="-122"/>
-                <a:cs typeface="Arial" pitchFamily="34" charset="-120"/>
+                <a:latin typeface="Arial" panose="020B0604020202020204" pitchFamily="34" charset="0"/>
+                <a:ea typeface="Arial" panose="020B0604020202020204" pitchFamily="34" charset="-122"/>
+                <a:cs typeface="Arial" panose="020B0604020202020204" pitchFamily="34" charset="-120"/>
               </a:rPr>
               <a:t>Interactive, NCERT-grounded study workspace for CBSE Class 10 — Maths &amp; Science.</a:t>
             </a:r>
@@ -1801,13 +1715,12 @@
             <a:avLst/>
           </a:prstGeom>
           <a:noFill/>
-          <a:ln/>
         </p:spPr>
         <p:txBody>
           <a:bodyPr wrap="square" rtlCol="0" anchor="ctr"/>
           <a:lstStyle/>
           <a:p>
-            <a:pPr indent="0" marL="0">
+            <a:pPr marL="0" indent="0">
               <a:buNone/>
             </a:pPr>
             <a:r>
@@ -1815,9 +1728,9 @@
                 <a:solidFill>
                   <a:srgbClr val="94A3B8"/>
                 </a:solidFill>
-                <a:latin typeface="Arial" pitchFamily="34" charset="0"/>
-                <a:ea typeface="Arial" pitchFamily="34" charset="-122"/>
-                <a:cs typeface="Arial" pitchFamily="34" charset="-120"/>
+                <a:latin typeface="Arial" panose="020B0604020202020204" pitchFamily="34" charset="0"/>
+                <a:ea typeface="Arial" panose="020B0604020202020204" pitchFamily="34" charset="-122"/>
+                <a:cs typeface="Arial" panose="020B0604020202020204" pitchFamily="34" charset="-120"/>
               </a:rPr>
               <a:t>An MVP proving the core idea: learn and generate notes at the same time, with zero effort. Built to scale to any class, subject, and a fully autonomous AI agent.</a:t>
             </a:r>
@@ -1844,7 +1757,6 @@
           <a:solidFill>
             <a:srgbClr val="F59E0B"/>
           </a:solidFill>
-          <a:ln/>
         </p:spPr>
       </p:sp>
       <p:sp>
@@ -1862,13 +1774,12 @@
             <a:avLst/>
           </a:prstGeom>
           <a:noFill/>
-          <a:ln/>
         </p:spPr>
         <p:txBody>
           <a:bodyPr wrap="square" rtlCol="0" anchor="ctr"/>
           <a:lstStyle/>
           <a:p>
-            <a:pPr algn="ctr" indent="0" marL="0">
+            <a:pPr marL="0" indent="0" algn="ctr">
               <a:buNone/>
             </a:pPr>
             <a:r>
@@ -1876,9 +1787,9 @@
                 <a:solidFill>
                   <a:srgbClr val="1A1A1A"/>
                 </a:solidFill>
-                <a:latin typeface="Arial" pitchFamily="34" charset="0"/>
-                <a:ea typeface="Arial" pitchFamily="34" charset="-122"/>
-                <a:cs typeface="Arial" pitchFamily="34" charset="-120"/>
+                <a:latin typeface="Arial" panose="020B0604020202020204" pitchFamily="34" charset="0"/>
+                <a:ea typeface="Arial" panose="020B0604020202020204" pitchFamily="34" charset="-122"/>
+                <a:cs typeface="Arial" panose="020B0604020202020204" pitchFamily="34" charset="-120"/>
               </a:rPr>
               <a:t>LIVE DEMO</a:t>
             </a:r>
@@ -1905,7 +1816,6 @@
           <a:solidFill>
             <a:srgbClr val="1A2440"/>
           </a:solidFill>
-          <a:ln/>
         </p:spPr>
       </p:sp>
       <p:sp>
@@ -1923,13 +1833,12 @@
             <a:avLst/>
           </a:prstGeom>
           <a:noFill/>
-          <a:ln/>
         </p:spPr>
         <p:txBody>
           <a:bodyPr wrap="square" rtlCol="0" anchor="ctr"/>
           <a:lstStyle/>
           <a:p>
-            <a:pPr algn="ctr" indent="0" marL="0">
+            <a:pPr marL="0" indent="0" algn="ctr">
               <a:buNone/>
             </a:pPr>
             <a:r>
@@ -1937,9 +1846,9 @@
                 <a:solidFill>
                   <a:srgbClr val="818CF8"/>
                 </a:solidFill>
-                <a:latin typeface="Arial" pitchFamily="34" charset="0"/>
-                <a:ea typeface="Arial" pitchFamily="34" charset="-122"/>
-                <a:cs typeface="Arial" pitchFamily="34" charset="-120"/>
+                <a:latin typeface="Arial" panose="020B0604020202020204" pitchFamily="34" charset="0"/>
+                <a:ea typeface="Arial" panose="020B0604020202020204" pitchFamily="34" charset="-122"/>
+                <a:cs typeface="Arial" panose="020B0604020202020204" pitchFamily="34" charset="-120"/>
               </a:rPr>
               <a:t>MVP · NEXT.JS 16</a:t>
             </a:r>
@@ -1962,13 +1871,12 @@
             <a:avLst/>
           </a:prstGeom>
           <a:noFill/>
-          <a:ln/>
         </p:spPr>
         <p:txBody>
           <a:bodyPr wrap="square" rtlCol="0" anchor="ctr"/>
           <a:lstStyle/>
           <a:p>
-            <a:pPr indent="0" marL="0">
+            <a:pPr marL="0" indent="0">
               <a:buNone/>
             </a:pPr>
             <a:r>
@@ -1976,9 +1884,9 @@
                 <a:solidFill>
                   <a:srgbClr val="94A3B8"/>
                 </a:solidFill>
-                <a:latin typeface="Arial" pitchFamily="34" charset="0"/>
-                <a:ea typeface="Arial" pitchFamily="34" charset="-122"/>
-                <a:cs typeface="Arial" pitchFamily="34" charset="-120"/>
+                <a:latin typeface="Arial" panose="020B0604020202020204" pitchFamily="34" charset="0"/>
+                <a:ea typeface="Arial" panose="020B0604020202020204" pitchFamily="34" charset="-122"/>
+                <a:cs typeface="Arial" panose="020B0604020202020204" pitchFamily="34" charset="-120"/>
               </a:rPr>
               <a:t>StudyNotes+</a:t>
             </a:r>
@@ -2001,13 +1909,12 @@
             <a:avLst/>
           </a:prstGeom>
           <a:noFill/>
-          <a:ln/>
         </p:spPr>
         <p:txBody>
           <a:bodyPr wrap="square" rtlCol="0" anchor="ctr"/>
           <a:lstStyle/>
           <a:p>
-            <a:pPr algn="r" indent="0" marL="0">
+            <a:pPr marL="0" indent="0" algn="r">
               <a:buNone/>
             </a:pPr>
             <a:r>
@@ -2015,9 +1922,9 @@
                 <a:solidFill>
                   <a:srgbClr val="94A3B8"/>
                 </a:solidFill>
-                <a:latin typeface="Arial" pitchFamily="34" charset="0"/>
-                <a:ea typeface="Arial" pitchFamily="34" charset="-122"/>
-                <a:cs typeface="Arial" pitchFamily="34" charset="-120"/>
+                <a:latin typeface="Arial" panose="020B0604020202020204" pitchFamily="34" charset="0"/>
+                <a:ea typeface="Arial" panose="020B0604020202020204" pitchFamily="34" charset="-122"/>
+                <a:cs typeface="Arial" panose="020B0604020202020204" pitchFamily="34" charset="-120"/>
               </a:rPr>
               <a:t>1 / 7</a:t>
             </a:r>
@@ -2035,12 +1942,13 @@
 
 <file path=ppt/slides/slide2.xml><?xml version="1.0" encoding="utf-8"?>
 <p:sld xmlns:a="http://schemas.openxmlformats.org/drawingml/2006/main" xmlns:r="http://schemas.openxmlformats.org/officeDocument/2006/relationships" xmlns:p="http://schemas.openxmlformats.org/presentationml/2006/main">
-  <p:cSld name="Slide 2">
+  <p:cSld>
     <p:bg>
       <p:bgPr>
         <a:solidFill>
           <a:srgbClr val="0B1020"/>
         </a:solidFill>
+        <a:effectLst/>
       </p:bgPr>
     </p:bg>
     <p:spTree>
@@ -2076,7 +1984,6 @@
               <a:alpha val="18000"/>
             </a:srgbClr>
           </a:solidFill>
-          <a:ln/>
         </p:spPr>
       </p:sp>
       <p:sp>
@@ -2098,7 +2005,6 @@
               <a:alpha val="12000"/>
             </a:srgbClr>
           </a:solidFill>
-          <a:ln/>
         </p:spPr>
       </p:sp>
       <p:sp>
@@ -2120,7 +2026,6 @@
               <a:alpha val="10000"/>
             </a:srgbClr>
           </a:solidFill>
-          <a:ln/>
         </p:spPr>
       </p:sp>
       <p:sp>
@@ -2138,13 +2043,12 @@
             <a:avLst/>
           </a:prstGeom>
           <a:noFill/>
-          <a:ln/>
         </p:spPr>
         <p:txBody>
           <a:bodyPr wrap="square" rtlCol="0" anchor="ctr"/>
           <a:lstStyle/>
           <a:p>
-            <a:pPr indent="0" marL="0">
+            <a:pPr marL="0" indent="0">
               <a:buNone/>
             </a:pPr>
             <a:r>
@@ -2152,9 +2056,9 @@
                 <a:solidFill>
                   <a:srgbClr val="F8FAFC"/>
                 </a:solidFill>
-                <a:latin typeface="Arial" pitchFamily="34" charset="0"/>
-                <a:ea typeface="Arial" pitchFamily="34" charset="-122"/>
-                <a:cs typeface="Arial" pitchFamily="34" charset="-120"/>
+                <a:latin typeface="Arial" panose="020B0604020202020204" pitchFamily="34" charset="0"/>
+                <a:ea typeface="Arial" panose="020B0604020202020204" pitchFamily="34" charset="-122"/>
+                <a:cs typeface="Arial" panose="020B0604020202020204" pitchFamily="34" charset="-120"/>
               </a:rPr>
               <a:t>The Problem</a:t>
             </a:r>
@@ -2177,13 +2081,12 @@
             <a:avLst/>
           </a:prstGeom>
           <a:noFill/>
-          <a:ln/>
         </p:spPr>
         <p:txBody>
           <a:bodyPr wrap="square" rtlCol="0" anchor="ctr"/>
           <a:lstStyle/>
           <a:p>
-            <a:pPr indent="0" marL="0">
+            <a:pPr marL="0" indent="0">
               <a:buNone/>
             </a:pPr>
             <a:r>
@@ -2191,9 +2094,9 @@
                 <a:solidFill>
                   <a:srgbClr val="94A3B8"/>
                 </a:solidFill>
-                <a:latin typeface="Arial" pitchFamily="34" charset="0"/>
-                <a:ea typeface="Arial" pitchFamily="34" charset="-122"/>
-                <a:cs typeface="Arial" pitchFamily="34" charset="-120"/>
+                <a:latin typeface="Arial" panose="020B0604020202020204" pitchFamily="34" charset="0"/>
+                <a:ea typeface="Arial" panose="020B0604020202020204" pitchFamily="34" charset="-122"/>
+                <a:cs typeface="Arial" panose="020B0604020202020204" pitchFamily="34" charset="-120"/>
               </a:rPr>
               <a:t>Students have content — but not study material they own or trust.</a:t>
             </a:r>
@@ -2220,7 +2123,6 @@
           <a:solidFill>
             <a:srgbClr val="F59E0B"/>
           </a:solidFill>
-          <a:ln/>
         </p:spPr>
       </p:sp>
       <p:sp>
@@ -2240,7 +2142,6 @@
           <a:solidFill>
             <a:srgbClr val="6366F1"/>
           </a:solidFill>
-          <a:ln/>
         </p:spPr>
       </p:sp>
       <p:sp>
@@ -2258,13 +2159,12 @@
             <a:avLst/>
           </a:prstGeom>
           <a:noFill/>
-          <a:ln/>
         </p:spPr>
         <p:txBody>
           <a:bodyPr wrap="square" rtlCol="0" anchor="t"/>
           <a:lstStyle/>
           <a:p>
-            <a:pPr indent="0" marL="0">
+            <a:pPr marL="0" indent="0">
               <a:lnSpc>
                 <a:spcPct val="105000"/>
               </a:lnSpc>
@@ -2275,9 +2175,9 @@
                 <a:solidFill>
                   <a:srgbClr val="F8FAFC"/>
                 </a:solidFill>
-                <a:latin typeface="Arial" pitchFamily="34" charset="0"/>
-                <a:ea typeface="Arial" pitchFamily="34" charset="-122"/>
-                <a:cs typeface="Arial" pitchFamily="34" charset="-120"/>
+                <a:latin typeface="Arial" panose="020B0604020202020204" pitchFamily="34" charset="0"/>
+                <a:ea typeface="Arial" panose="020B0604020202020204" pitchFamily="34" charset="-122"/>
+                <a:cs typeface="Arial" panose="020B0604020202020204" pitchFamily="34" charset="-120"/>
               </a:rPr>
               <a:t>NCERT textbooks are long and unstructured — turning 300 pages into revision notes is slow and tedious.</a:t>
             </a:r>
@@ -2302,7 +2202,6 @@
           <a:solidFill>
             <a:srgbClr val="F59E0B"/>
           </a:solidFill>
-          <a:ln/>
         </p:spPr>
       </p:sp>
       <p:sp>
@@ -2320,13 +2219,12 @@
             <a:avLst/>
           </a:prstGeom>
           <a:noFill/>
-          <a:ln/>
         </p:spPr>
         <p:txBody>
           <a:bodyPr wrap="square" rtlCol="0" anchor="t"/>
           <a:lstStyle/>
           <a:p>
-            <a:pPr indent="0" marL="0">
+            <a:pPr marL="0" indent="0">
               <a:lnSpc>
                 <a:spcPct val="105000"/>
               </a:lnSpc>
@@ -2337,9 +2235,9 @@
                 <a:solidFill>
                   <a:srgbClr val="F8FAFC"/>
                 </a:solidFill>
-                <a:latin typeface="Arial" pitchFamily="34" charset="0"/>
-                <a:ea typeface="Arial" pitchFamily="34" charset="-122"/>
-                <a:cs typeface="Arial" pitchFamily="34" charset="-120"/>
+                <a:latin typeface="Arial" panose="020B0604020202020204" pitchFamily="34" charset="0"/>
+                <a:ea typeface="Arial" panose="020B0604020202020204" pitchFamily="34" charset="-122"/>
+                <a:cs typeface="Arial" panose="020B0604020202020204" pitchFamily="34" charset="-120"/>
               </a:rPr>
               <a:t>Generic AI chat gives answers that may be wrong, off-syllabus, or impossible to verify.</a:t>
             </a:r>
@@ -2364,7 +2262,6 @@
           <a:solidFill>
             <a:srgbClr val="6366F1"/>
           </a:solidFill>
-          <a:ln/>
         </p:spPr>
       </p:sp>
       <p:sp>
@@ -2382,13 +2279,12 @@
             <a:avLst/>
           </a:prstGeom>
           <a:noFill/>
-          <a:ln/>
         </p:spPr>
         <p:txBody>
           <a:bodyPr wrap="square" rtlCol="0" anchor="t"/>
           <a:lstStyle/>
           <a:p>
-            <a:pPr indent="0" marL="0">
+            <a:pPr marL="0" indent="0">
               <a:lnSpc>
                 <a:spcPct val="105000"/>
               </a:lnSpc>
@@ -2399,9 +2295,9 @@
                 <a:solidFill>
                   <a:srgbClr val="F8FAFC"/>
                 </a:solidFill>
-                <a:latin typeface="Arial" pitchFamily="34" charset="0"/>
-                <a:ea typeface="Arial" pitchFamily="34" charset="-122"/>
-                <a:cs typeface="Arial" pitchFamily="34" charset="-120"/>
+                <a:latin typeface="Arial" panose="020B0604020202020204" pitchFamily="34" charset="0"/>
+                <a:ea typeface="Arial" panose="020B0604020202020204" pitchFamily="34" charset="-122"/>
+                <a:cs typeface="Arial" panose="020B0604020202020204" pitchFamily="34" charset="-120"/>
               </a:rPr>
               <a:t>Useful notes typed in chat disappear — there is no single editable, owned revision document.</a:t>
             </a:r>
@@ -2426,7 +2322,6 @@
           <a:solidFill>
             <a:srgbClr val="F59E0B"/>
           </a:solidFill>
-          <a:ln/>
         </p:spPr>
       </p:sp>
       <p:sp>
@@ -2444,13 +2339,12 @@
             <a:avLst/>
           </a:prstGeom>
           <a:noFill/>
-          <a:ln/>
         </p:spPr>
         <p:txBody>
           <a:bodyPr wrap="square" rtlCol="0" anchor="t"/>
           <a:lstStyle/>
           <a:p>
-            <a:pPr indent="0" marL="0">
+            <a:pPr marL="0" indent="0">
               <a:lnSpc>
                 <a:spcPct val="105000"/>
               </a:lnSpc>
@@ -2461,9 +2355,9 @@
                 <a:solidFill>
                   <a:srgbClr val="F8FAFC"/>
                 </a:solidFill>
-                <a:latin typeface="Arial" pitchFamily="34" charset="0"/>
-                <a:ea typeface="Arial" pitchFamily="34" charset="-122"/>
-                <a:cs typeface="Arial" pitchFamily="34" charset="-120"/>
+                <a:latin typeface="Arial" panose="020B0604020202020204" pitchFamily="34" charset="0"/>
+                <a:ea typeface="Arial" panose="020B0604020202020204" pitchFamily="34" charset="-122"/>
+                <a:cs typeface="Arial" panose="020B0604020202020204" pitchFamily="34" charset="-120"/>
               </a:rPr>
               <a:t>Students can't safely ask the AI to restructure their own notes without risking lost work.</a:t>
             </a:r>
@@ -2479,7 +2373,7 @@
         </p:nvSpPr>
         <p:spPr>
           <a:xfrm>
-            <a:off x="9509760" y="1783080"/>
+            <a:off x="9646920" y="2101850"/>
             <a:ext cx="2011680" cy="3291840"/>
           </a:xfrm>
           <a:prstGeom prst="roundRect">
@@ -2506,20 +2400,19 @@
         </p:nvSpPr>
         <p:spPr>
           <a:xfrm>
-            <a:off x="9509760" y="2011680"/>
+            <a:off x="9540240" y="2194560"/>
             <a:ext cx="2011680" cy="731520"/>
           </a:xfrm>
           <a:prstGeom prst="rect">
             <a:avLst/>
           </a:prstGeom>
           <a:noFill/>
-          <a:ln/>
         </p:spPr>
         <p:txBody>
           <a:bodyPr wrap="square" rtlCol="0" anchor="ctr"/>
           <a:lstStyle/>
           <a:p>
-            <a:pPr algn="ctr" indent="0" marL="0">
+            <a:pPr marL="0" indent="0" algn="ctr">
               <a:buNone/>
             </a:pPr>
             <a:r>
@@ -2527,9 +2420,9 @@
                 <a:solidFill>
                   <a:srgbClr val="F59E0B"/>
                 </a:solidFill>
-                <a:latin typeface="Arial" pitchFamily="34" charset="0"/>
-                <a:ea typeface="Arial" pitchFamily="34" charset="-122"/>
-                <a:cs typeface="Arial" pitchFamily="34" charset="-120"/>
+                <a:latin typeface="Arial" panose="020B0604020202020204" pitchFamily="34" charset="0"/>
+                <a:ea typeface="Arial" panose="020B0604020202020204" pitchFamily="34" charset="-122"/>
+                <a:cs typeface="Arial" panose="020B0604020202020204" pitchFamily="34" charset="-120"/>
               </a:rPr>
               <a:t>300+</a:t>
             </a:r>
@@ -2545,20 +2438,19 @@
         </p:nvSpPr>
         <p:spPr>
           <a:xfrm>
-            <a:off x="9509760" y="2743200"/>
+            <a:off x="9540240" y="2926080"/>
             <a:ext cx="2011680" cy="731520"/>
           </a:xfrm>
           <a:prstGeom prst="rect">
             <a:avLst/>
           </a:prstGeom>
           <a:noFill/>
-          <a:ln/>
         </p:spPr>
         <p:txBody>
           <a:bodyPr wrap="square" rtlCol="0" anchor="ctr"/>
           <a:lstStyle/>
           <a:p>
-            <a:pPr algn="ctr" indent="0" marL="0">
+            <a:pPr marL="0" indent="0" algn="ctr">
               <a:buNone/>
             </a:pPr>
             <a:r>
@@ -2566,16 +2458,16 @@
                 <a:solidFill>
                   <a:srgbClr val="94A3B8"/>
                 </a:solidFill>
-                <a:latin typeface="Arial" pitchFamily="34" charset="0"/>
-                <a:ea typeface="Arial" pitchFamily="34" charset="-122"/>
-                <a:cs typeface="Arial" pitchFamily="34" charset="-120"/>
+                <a:latin typeface="Arial" panose="020B0604020202020204" pitchFamily="34" charset="0"/>
+                <a:ea typeface="Arial" panose="020B0604020202020204" pitchFamily="34" charset="-122"/>
+                <a:cs typeface="Arial" panose="020B0604020202020204" pitchFamily="34" charset="-120"/>
               </a:rPr>
               <a:t>pages per</a:t>
             </a:r>
             <a:endParaRPr lang="en-US" sz="1200" dirty="0"/>
           </a:p>
           <a:p>
-            <a:pPr algn="ctr" indent="0" marL="0">
+            <a:pPr marL="0" indent="0" algn="ctr">
               <a:buNone/>
             </a:pPr>
             <a:r>
@@ -2583,9 +2475,9 @@
                 <a:solidFill>
                   <a:srgbClr val="94A3B8"/>
                 </a:solidFill>
-                <a:latin typeface="Arial" pitchFamily="34" charset="0"/>
-                <a:ea typeface="Arial" pitchFamily="34" charset="-122"/>
-                <a:cs typeface="Arial" pitchFamily="34" charset="-120"/>
+                <a:latin typeface="Arial" panose="020B0604020202020204" pitchFamily="34" charset="0"/>
+                <a:ea typeface="Arial" panose="020B0604020202020204" pitchFamily="34" charset="-122"/>
+                <a:cs typeface="Arial" panose="020B0604020202020204" pitchFamily="34" charset="-120"/>
               </a:rPr>
               <a:t>NCERT book</a:t>
             </a:r>
@@ -2601,20 +2493,19 @@
         </p:nvSpPr>
         <p:spPr>
           <a:xfrm>
-            <a:off x="9509760" y="3566160"/>
+            <a:off x="9540240" y="3749040"/>
             <a:ext cx="2011680" cy="731520"/>
           </a:xfrm>
           <a:prstGeom prst="rect">
             <a:avLst/>
           </a:prstGeom>
           <a:noFill/>
-          <a:ln/>
         </p:spPr>
         <p:txBody>
           <a:bodyPr wrap="square" rtlCol="0" anchor="ctr"/>
           <a:lstStyle/>
           <a:p>
-            <a:pPr algn="ctr" indent="0" marL="0">
+            <a:pPr marL="0" indent="0" algn="ctr">
               <a:buNone/>
             </a:pPr>
             <a:r>
@@ -2622,9 +2513,9 @@
                 <a:solidFill>
                   <a:srgbClr val="818CF8"/>
                 </a:solidFill>
-                <a:latin typeface="Arial" pitchFamily="34" charset="0"/>
-                <a:ea typeface="Arial" pitchFamily="34" charset="-122"/>
-                <a:cs typeface="Arial" pitchFamily="34" charset="-120"/>
+                <a:latin typeface="Arial" panose="020B0604020202020204" pitchFamily="34" charset="0"/>
+                <a:ea typeface="Arial" panose="020B0604020202020204" pitchFamily="34" charset="-122"/>
+                <a:cs typeface="Arial" panose="020B0604020202020204" pitchFamily="34" charset="-120"/>
               </a:rPr>
               <a:t>0</a:t>
             </a:r>
@@ -2640,20 +2531,19 @@
         </p:nvSpPr>
         <p:spPr>
           <a:xfrm>
-            <a:off x="9509760" y="4297680"/>
+            <a:off x="9540240" y="4480560"/>
             <a:ext cx="2011680" cy="731520"/>
           </a:xfrm>
           <a:prstGeom prst="rect">
             <a:avLst/>
           </a:prstGeom>
           <a:noFill/>
-          <a:ln/>
         </p:spPr>
         <p:txBody>
           <a:bodyPr wrap="square" rtlCol="0" anchor="ctr"/>
           <a:lstStyle/>
           <a:p>
-            <a:pPr algn="ctr" indent="0" marL="0">
+            <a:pPr marL="0" indent="0" algn="ctr">
               <a:buNone/>
             </a:pPr>
             <a:r>
@@ -2661,16 +2551,16 @@
                 <a:solidFill>
                   <a:srgbClr val="94A3B8"/>
                 </a:solidFill>
-                <a:latin typeface="Arial" pitchFamily="34" charset="0"/>
-                <a:ea typeface="Arial" pitchFamily="34" charset="-122"/>
-                <a:cs typeface="Arial" pitchFamily="34" charset="-120"/>
+                <a:latin typeface="Arial" panose="020B0604020202020204" pitchFamily="34" charset="0"/>
+                <a:ea typeface="Arial" panose="020B0604020202020204" pitchFamily="34" charset="-122"/>
+                <a:cs typeface="Arial" panose="020B0604020202020204" pitchFamily="34" charset="-120"/>
               </a:rPr>
               <a:t>owned, editable</a:t>
             </a:r>
             <a:endParaRPr lang="en-US" sz="1200" dirty="0"/>
           </a:p>
           <a:p>
-            <a:pPr algn="ctr" indent="0" marL="0">
+            <a:pPr marL="0" indent="0" algn="ctr">
               <a:buNone/>
             </a:pPr>
             <a:r>
@@ -2678,9 +2568,9 @@
                 <a:solidFill>
                   <a:srgbClr val="94A3B8"/>
                 </a:solidFill>
-                <a:latin typeface="Arial" pitchFamily="34" charset="0"/>
-                <a:ea typeface="Arial" pitchFamily="34" charset="-122"/>
-                <a:cs typeface="Arial" pitchFamily="34" charset="-120"/>
+                <a:latin typeface="Arial" panose="020B0604020202020204" pitchFamily="34" charset="0"/>
+                <a:ea typeface="Arial" panose="020B0604020202020204" pitchFamily="34" charset="-122"/>
+                <a:cs typeface="Arial" panose="020B0604020202020204" pitchFamily="34" charset="-120"/>
               </a:rPr>
               <a:t>revision docs</a:t>
             </a:r>
@@ -2703,13 +2593,12 @@
             <a:avLst/>
           </a:prstGeom>
           <a:noFill/>
-          <a:ln/>
         </p:spPr>
         <p:txBody>
           <a:bodyPr wrap="square" rtlCol="0" anchor="ctr"/>
           <a:lstStyle/>
           <a:p>
-            <a:pPr indent="0" marL="0">
+            <a:pPr marL="0" indent="0">
               <a:buNone/>
             </a:pPr>
             <a:r>
@@ -2717,9 +2606,9 @@
                 <a:solidFill>
                   <a:srgbClr val="94A3B8"/>
                 </a:solidFill>
-                <a:latin typeface="Arial" pitchFamily="34" charset="0"/>
-                <a:ea typeface="Arial" pitchFamily="34" charset="-122"/>
-                <a:cs typeface="Arial" pitchFamily="34" charset="-120"/>
+                <a:latin typeface="Arial" panose="020B0604020202020204" pitchFamily="34" charset="0"/>
+                <a:ea typeface="Arial" panose="020B0604020202020204" pitchFamily="34" charset="-122"/>
+                <a:cs typeface="Arial" panose="020B0604020202020204" pitchFamily="34" charset="-120"/>
               </a:rPr>
               <a:t>StudyNotes+</a:t>
             </a:r>
@@ -2742,13 +2631,12 @@
             <a:avLst/>
           </a:prstGeom>
           <a:noFill/>
-          <a:ln/>
         </p:spPr>
         <p:txBody>
           <a:bodyPr wrap="square" rtlCol="0" anchor="ctr"/>
           <a:lstStyle/>
           <a:p>
-            <a:pPr algn="r" indent="0" marL="0">
+            <a:pPr marL="0" indent="0" algn="r">
               <a:buNone/>
             </a:pPr>
             <a:r>
@@ -2756,9 +2644,9 @@
                 <a:solidFill>
                   <a:srgbClr val="94A3B8"/>
                 </a:solidFill>
-                <a:latin typeface="Arial" pitchFamily="34" charset="0"/>
-                <a:ea typeface="Arial" pitchFamily="34" charset="-122"/>
-                <a:cs typeface="Arial" pitchFamily="34" charset="-120"/>
+                <a:latin typeface="Arial" panose="020B0604020202020204" pitchFamily="34" charset="0"/>
+                <a:ea typeface="Arial" panose="020B0604020202020204" pitchFamily="34" charset="-122"/>
+                <a:cs typeface="Arial" panose="020B0604020202020204" pitchFamily="34" charset="-120"/>
               </a:rPr>
               <a:t>2 / 7</a:t>
             </a:r>
@@ -2776,12 +2664,13 @@
 
 <file path=ppt/slides/slide3.xml><?xml version="1.0" encoding="utf-8"?>
 <p:sld xmlns:a="http://schemas.openxmlformats.org/drawingml/2006/main" xmlns:r="http://schemas.openxmlformats.org/officeDocument/2006/relationships" xmlns:p="http://schemas.openxmlformats.org/presentationml/2006/main">
-  <p:cSld name="Slide 3">
+  <p:cSld>
     <p:bg>
       <p:bgPr>
         <a:solidFill>
           <a:srgbClr val="0B1020"/>
         </a:solidFill>
+        <a:effectLst/>
       </p:bgPr>
     </p:bg>
     <p:spTree>
@@ -2817,7 +2706,6 @@
               <a:alpha val="18000"/>
             </a:srgbClr>
           </a:solidFill>
-          <a:ln/>
         </p:spPr>
       </p:sp>
       <p:sp>
@@ -2839,7 +2727,6 @@
               <a:alpha val="12000"/>
             </a:srgbClr>
           </a:solidFill>
-          <a:ln/>
         </p:spPr>
       </p:sp>
       <p:sp>
@@ -2861,7 +2748,6 @@
               <a:alpha val="10000"/>
             </a:srgbClr>
           </a:solidFill>
-          <a:ln/>
         </p:spPr>
       </p:sp>
       <p:sp>
@@ -2879,13 +2765,12 @@
             <a:avLst/>
           </a:prstGeom>
           <a:noFill/>
-          <a:ln/>
         </p:spPr>
         <p:txBody>
           <a:bodyPr wrap="square" rtlCol="0" anchor="ctr"/>
           <a:lstStyle/>
           <a:p>
-            <a:pPr indent="0" marL="0">
+            <a:pPr marL="0" indent="0">
               <a:buNone/>
             </a:pPr>
             <a:r>
@@ -2893,9 +2778,9 @@
                 <a:solidFill>
                   <a:srgbClr val="F8FAFC"/>
                 </a:solidFill>
-                <a:latin typeface="Arial" pitchFamily="34" charset="0"/>
-                <a:ea typeface="Arial" pitchFamily="34" charset="-122"/>
-                <a:cs typeface="Arial" pitchFamily="34" charset="-120"/>
+                <a:latin typeface="Arial" panose="020B0604020202020204" pitchFamily="34" charset="0"/>
+                <a:ea typeface="Arial" panose="020B0604020202020204" pitchFamily="34" charset="-122"/>
+                <a:cs typeface="Arial" panose="020B0604020202020204" pitchFamily="34" charset="-120"/>
               </a:rPr>
               <a:t>Our Solution</a:t>
             </a:r>
@@ -2918,13 +2803,12 @@
             <a:avLst/>
           </a:prstGeom>
           <a:noFill/>
-          <a:ln/>
         </p:spPr>
         <p:txBody>
           <a:bodyPr wrap="square" rtlCol="0" anchor="ctr"/>
           <a:lstStyle/>
           <a:p>
-            <a:pPr indent="0" marL="0">
+            <a:pPr marL="0" indent="0">
               <a:buNone/>
             </a:pPr>
             <a:r>
@@ -2932,9 +2816,9 @@
                 <a:solidFill>
                   <a:srgbClr val="94A3B8"/>
                 </a:solidFill>
-                <a:latin typeface="Arial" pitchFamily="34" charset="0"/>
-                <a:ea typeface="Arial" pitchFamily="34" charset="-122"/>
-                <a:cs typeface="Arial" pitchFamily="34" charset="-120"/>
+                <a:latin typeface="Arial" panose="020B0604020202020204" pitchFamily="34" charset="0"/>
+                <a:ea typeface="Arial" panose="020B0604020202020204" pitchFamily="34" charset="-122"/>
+                <a:cs typeface="Arial" panose="020B0604020202020204" pitchFamily="34" charset="-120"/>
               </a:rPr>
               <a:t>NCERT-grounded chat + a student-owned, AI-editable notes canvas.</a:t>
             </a:r>
@@ -2961,7 +2845,6 @@
           <a:solidFill>
             <a:srgbClr val="F59E0B"/>
           </a:solidFill>
-          <a:ln/>
         </p:spPr>
       </p:sp>
       <p:sp>
@@ -3010,7 +2893,6 @@
           <a:solidFill>
             <a:srgbClr val="6366F1"/>
           </a:solidFill>
-          <a:ln/>
         </p:spPr>
       </p:sp>
       <p:sp>
@@ -3028,13 +2910,12 @@
             <a:avLst/>
           </a:prstGeom>
           <a:noFill/>
-          <a:ln/>
         </p:spPr>
         <p:txBody>
           <a:bodyPr wrap="square" rtlCol="0" anchor="ctr"/>
           <a:lstStyle/>
           <a:p>
-            <a:pPr indent="0" marL="0">
+            <a:pPr marL="0" indent="0">
               <a:buNone/>
             </a:pPr>
             <a:r>
@@ -3042,9 +2923,9 @@
                 <a:solidFill>
                   <a:srgbClr val="F8FAFC"/>
                 </a:solidFill>
-                <a:latin typeface="Arial" pitchFamily="34" charset="0"/>
-                <a:ea typeface="Arial" pitchFamily="34" charset="-122"/>
-                <a:cs typeface="Arial" pitchFamily="34" charset="-120"/>
+                <a:latin typeface="Arial" panose="020B0604020202020204" pitchFamily="34" charset="0"/>
+                <a:ea typeface="Arial" panose="020B0604020202020204" pitchFamily="34" charset="-122"/>
+                <a:cs typeface="Arial" panose="020B0604020202020204" pitchFamily="34" charset="-120"/>
               </a:rPr>
               <a:t>Explain / Solve</a:t>
             </a:r>
@@ -3067,13 +2948,12 @@
             <a:avLst/>
           </a:prstGeom>
           <a:noFill/>
-          <a:ln/>
         </p:spPr>
         <p:txBody>
           <a:bodyPr wrap="square" rtlCol="0" anchor="ctr"/>
           <a:lstStyle/>
           <a:p>
-            <a:pPr indent="0" marL="0">
+            <a:pPr marL="0" indent="0">
               <a:lnSpc>
                 <a:spcPct val="105000"/>
               </a:lnSpc>
@@ -3084,9 +2964,9 @@
                 <a:solidFill>
                   <a:srgbClr val="94A3B8"/>
                 </a:solidFill>
-                <a:latin typeface="Arial" pitchFamily="34" charset="0"/>
-                <a:ea typeface="Arial" pitchFamily="34" charset="-122"/>
-                <a:cs typeface="Arial" pitchFamily="34" charset="-120"/>
+                <a:latin typeface="Arial" panose="020B0604020202020204" pitchFamily="34" charset="0"/>
+                <a:ea typeface="Arial" panose="020B0604020202020204" pitchFamily="34" charset="-122"/>
+                <a:cs typeface="Arial" panose="020B0604020202020204" pitchFamily="34" charset="-120"/>
               </a:rPr>
               <a:t>RAG over approved NCERT chunks with source citations.</a:t>
             </a:r>
@@ -3140,7 +3020,6 @@
           <a:solidFill>
             <a:srgbClr val="F59E0B"/>
           </a:solidFill>
-          <a:ln/>
         </p:spPr>
       </p:sp>
       <p:sp>
@@ -3158,13 +3037,12 @@
             <a:avLst/>
           </a:prstGeom>
           <a:noFill/>
-          <a:ln/>
         </p:spPr>
         <p:txBody>
           <a:bodyPr wrap="square" rtlCol="0" anchor="ctr"/>
           <a:lstStyle/>
           <a:p>
-            <a:pPr indent="0" marL="0">
+            <a:pPr marL="0" indent="0">
               <a:buNone/>
             </a:pPr>
             <a:r>
@@ -3172,9 +3050,9 @@
                 <a:solidFill>
                   <a:srgbClr val="F8FAFC"/>
                 </a:solidFill>
-                <a:latin typeface="Arial" pitchFamily="34" charset="0"/>
-                <a:ea typeface="Arial" pitchFamily="34" charset="-122"/>
-                <a:cs typeface="Arial" pitchFamily="34" charset="-120"/>
+                <a:latin typeface="Arial" panose="020B0604020202020204" pitchFamily="34" charset="0"/>
+                <a:ea typeface="Arial" panose="020B0604020202020204" pitchFamily="34" charset="-122"/>
+                <a:cs typeface="Arial" panose="020B0604020202020204" pitchFamily="34" charset="-120"/>
               </a:rPr>
               <a:t>Generate Notes</a:t>
             </a:r>
@@ -3197,13 +3075,12 @@
             <a:avLst/>
           </a:prstGeom>
           <a:noFill/>
-          <a:ln/>
         </p:spPr>
         <p:txBody>
           <a:bodyPr wrap="square" rtlCol="0" anchor="ctr"/>
           <a:lstStyle/>
           <a:p>
-            <a:pPr indent="0" marL="0">
+            <a:pPr marL="0" indent="0">
               <a:lnSpc>
                 <a:spcPct val="105000"/>
               </a:lnSpc>
@@ -3214,9 +3091,9 @@
                 <a:solidFill>
                   <a:srgbClr val="94A3B8"/>
                 </a:solidFill>
-                <a:latin typeface="Arial" pitchFamily="34" charset="0"/>
-                <a:ea typeface="Arial" pitchFamily="34" charset="-122"/>
-                <a:cs typeface="Arial" pitchFamily="34" charset="-120"/>
+                <a:latin typeface="Arial" panose="020B0604020202020204" pitchFamily="34" charset="0"/>
+                <a:ea typeface="Arial" panose="020B0604020202020204" pitchFamily="34" charset="-122"/>
+                <a:cs typeface="Arial" panose="020B0604020202020204" pitchFamily="34" charset="-120"/>
               </a:rPr>
               <a:t>AI drafts a structured revision document straight into the canvas.</a:t>
             </a:r>
@@ -3270,7 +3147,6 @@
           <a:solidFill>
             <a:srgbClr val="2DD4BF"/>
           </a:solidFill>
-          <a:ln/>
         </p:spPr>
       </p:sp>
       <p:sp>
@@ -3288,13 +3164,12 @@
             <a:avLst/>
           </a:prstGeom>
           <a:noFill/>
-          <a:ln/>
         </p:spPr>
         <p:txBody>
           <a:bodyPr wrap="square" rtlCol="0" anchor="ctr"/>
           <a:lstStyle/>
           <a:p>
-            <a:pPr indent="0" marL="0">
+            <a:pPr marL="0" indent="0">
               <a:buNone/>
             </a:pPr>
             <a:r>
@@ -3302,9 +3177,9 @@
                 <a:solidFill>
                   <a:srgbClr val="F8FAFC"/>
                 </a:solidFill>
-                <a:latin typeface="Arial" pitchFamily="34" charset="0"/>
-                <a:ea typeface="Arial" pitchFamily="34" charset="-122"/>
-                <a:cs typeface="Arial" pitchFamily="34" charset="-120"/>
+                <a:latin typeface="Arial" panose="020B0604020202020204" pitchFamily="34" charset="0"/>
+                <a:ea typeface="Arial" panose="020B0604020202020204" pitchFamily="34" charset="-122"/>
+                <a:cs typeface="Arial" panose="020B0604020202020204" pitchFamily="34" charset="-120"/>
               </a:rPr>
               <a:t>AI Commands</a:t>
             </a:r>
@@ -3327,13 +3202,12 @@
             <a:avLst/>
           </a:prstGeom>
           <a:noFill/>
-          <a:ln/>
         </p:spPr>
         <p:txBody>
           <a:bodyPr wrap="square" rtlCol="0" anchor="ctr"/>
           <a:lstStyle/>
           <a:p>
-            <a:pPr indent="0" marL="0">
+            <a:pPr marL="0" indent="0">
               <a:lnSpc>
                 <a:spcPct val="105000"/>
               </a:lnSpc>
@@ -3344,9 +3218,9 @@
                 <a:solidFill>
                   <a:srgbClr val="94A3B8"/>
                 </a:solidFill>
-                <a:latin typeface="Arial" pitchFamily="34" charset="0"/>
-                <a:ea typeface="Arial" pitchFamily="34" charset="-122"/>
-                <a:cs typeface="Arial" pitchFamily="34" charset="-120"/>
+                <a:latin typeface="Arial" panose="020B0604020202020204" pitchFamily="34" charset="0"/>
+                <a:ea typeface="Arial" panose="020B0604020202020204" pitchFamily="34" charset="-122"/>
+                <a:cs typeface="Arial" panose="020B0604020202020204" pitchFamily="34" charset="-120"/>
               </a:rPr>
               <a:t>"Highlight key points", "add a derivation", "reorder" — applied safely.</a:t>
             </a:r>
@@ -3400,7 +3274,6 @@
           <a:solidFill>
             <a:srgbClr val="818CF8"/>
           </a:solidFill>
-          <a:ln/>
         </p:spPr>
       </p:sp>
       <p:sp>
@@ -3418,13 +3291,12 @@
             <a:avLst/>
           </a:prstGeom>
           <a:noFill/>
-          <a:ln/>
         </p:spPr>
         <p:txBody>
           <a:bodyPr wrap="square" rtlCol="0" anchor="ctr"/>
           <a:lstStyle/>
           <a:p>
-            <a:pPr indent="0" marL="0">
+            <a:pPr marL="0" indent="0">
               <a:buNone/>
             </a:pPr>
             <a:r>
@@ -3432,9 +3304,9 @@
                 <a:solidFill>
                   <a:srgbClr val="F8FAFC"/>
                 </a:solidFill>
-                <a:latin typeface="Arial" pitchFamily="34" charset="0"/>
-                <a:ea typeface="Arial" pitchFamily="34" charset="-122"/>
-                <a:cs typeface="Arial" pitchFamily="34" charset="-120"/>
+                <a:latin typeface="Arial" panose="020B0604020202020204" pitchFamily="34" charset="0"/>
+                <a:ea typeface="Arial" panose="020B0604020202020204" pitchFamily="34" charset="-122"/>
+                <a:cs typeface="Arial" panose="020B0604020202020204" pitchFamily="34" charset="-120"/>
               </a:rPr>
               <a:t>Manual + LaTeX</a:t>
             </a:r>
@@ -3457,13 +3329,12 @@
             <a:avLst/>
           </a:prstGeom>
           <a:noFill/>
-          <a:ln/>
         </p:spPr>
         <p:txBody>
           <a:bodyPr wrap="square" rtlCol="0" anchor="ctr"/>
           <a:lstStyle/>
           <a:p>
-            <a:pPr indent="0" marL="0">
+            <a:pPr marL="0" indent="0">
               <a:lnSpc>
                 <a:spcPct val="105000"/>
               </a:lnSpc>
@@ -3474,9 +3345,9 @@
                 <a:solidFill>
                   <a:srgbClr val="94A3B8"/>
                 </a:solidFill>
-                <a:latin typeface="Arial" pitchFamily="34" charset="0"/>
-                <a:ea typeface="Arial" pitchFamily="34" charset="-122"/>
-                <a:cs typeface="Arial" pitchFamily="34" charset="-120"/>
+                <a:latin typeface="Arial" panose="020B0604020202020204" pitchFamily="34" charset="0"/>
+                <a:ea typeface="Arial" panose="020B0604020202020204" pitchFamily="34" charset="-122"/>
+                <a:cs typeface="Arial" panose="020B0604020202020204" pitchFamily="34" charset="-120"/>
               </a:rPr>
               <a:t>Edit Markdown; KaTeX renders formulas correctly.</a:t>
             </a:r>
@@ -3530,7 +3401,6 @@
           <a:solidFill>
             <a:srgbClr val="FBBF24"/>
           </a:solidFill>
-          <a:ln/>
         </p:spPr>
       </p:sp>
       <p:sp>
@@ -3548,13 +3418,12 @@
             <a:avLst/>
           </a:prstGeom>
           <a:noFill/>
-          <a:ln/>
         </p:spPr>
         <p:txBody>
           <a:bodyPr wrap="square" rtlCol="0" anchor="ctr"/>
           <a:lstStyle/>
           <a:p>
-            <a:pPr indent="0" marL="0">
+            <a:pPr marL="0" indent="0">
               <a:buNone/>
             </a:pPr>
             <a:r>
@@ -3562,9 +3431,9 @@
                 <a:solidFill>
                   <a:srgbClr val="F8FAFC"/>
                 </a:solidFill>
-                <a:latin typeface="Arial" pitchFamily="34" charset="0"/>
-                <a:ea typeface="Arial" pitchFamily="34" charset="-122"/>
-                <a:cs typeface="Arial" pitchFamily="34" charset="-120"/>
+                <a:latin typeface="Arial" panose="020B0604020202020204" pitchFamily="34" charset="0"/>
+                <a:ea typeface="Arial" panose="020B0604020202020204" pitchFamily="34" charset="-122"/>
+                <a:cs typeface="Arial" panose="020B0604020202020204" pitchFamily="34" charset="-120"/>
               </a:rPr>
               <a:t>Revisions</a:t>
             </a:r>
@@ -3587,13 +3456,12 @@
             <a:avLst/>
           </a:prstGeom>
           <a:noFill/>
-          <a:ln/>
         </p:spPr>
         <p:txBody>
           <a:bodyPr wrap="square" rtlCol="0" anchor="ctr"/>
           <a:lstStyle/>
           <a:p>
-            <a:pPr indent="0" marL="0">
+            <a:pPr marL="0" indent="0">
               <a:lnSpc>
                 <a:spcPct val="105000"/>
               </a:lnSpc>
@@ -3604,9 +3472,9 @@
                 <a:solidFill>
                   <a:srgbClr val="94A3B8"/>
                 </a:solidFill>
-                <a:latin typeface="Arial" pitchFamily="34" charset="0"/>
-                <a:ea typeface="Arial" pitchFamily="34" charset="-122"/>
-                <a:cs typeface="Arial" pitchFamily="34" charset="-120"/>
+                <a:latin typeface="Arial" panose="020B0604020202020204" pitchFamily="34" charset="0"/>
+                <a:ea typeface="Arial" panose="020B0604020202020204" pitchFamily="34" charset="-122"/>
+                <a:cs typeface="Arial" panose="020B0604020202020204" pitchFamily="34" charset="-120"/>
               </a:rPr>
               <a:t>Undo, version history and conflict handling on every change.</a:t>
             </a:r>
@@ -3660,7 +3528,6 @@
           <a:solidFill>
             <a:srgbClr val="6366F1"/>
           </a:solidFill>
-          <a:ln/>
         </p:spPr>
       </p:sp>
       <p:sp>
@@ -3678,13 +3545,12 @@
             <a:avLst/>
           </a:prstGeom>
           <a:noFill/>
-          <a:ln/>
         </p:spPr>
         <p:txBody>
           <a:bodyPr wrap="square" rtlCol="0" anchor="ctr"/>
           <a:lstStyle/>
           <a:p>
-            <a:pPr indent="0" marL="0">
+            <a:pPr marL="0" indent="0">
               <a:buNone/>
             </a:pPr>
             <a:r>
@@ -3692,9 +3558,9 @@
                 <a:solidFill>
                   <a:srgbClr val="F8FAFC"/>
                 </a:solidFill>
-                <a:latin typeface="Arial" pitchFamily="34" charset="0"/>
-                <a:ea typeface="Arial" pitchFamily="34" charset="-122"/>
-                <a:cs typeface="Arial" pitchFamily="34" charset="-120"/>
+                <a:latin typeface="Arial" panose="020B0604020202020204" pitchFamily="34" charset="0"/>
+                <a:ea typeface="Arial" panose="020B0604020202020204" pitchFamily="34" charset="-122"/>
+                <a:cs typeface="Arial" panose="020B0604020202020204" pitchFamily="34" charset="-120"/>
               </a:rPr>
               <a:t>Side-by-side</a:t>
             </a:r>
@@ -3717,13 +3583,12 @@
             <a:avLst/>
           </a:prstGeom>
           <a:noFill/>
-          <a:ln/>
         </p:spPr>
         <p:txBody>
           <a:bodyPr wrap="square" rtlCol="0" anchor="ctr"/>
           <a:lstStyle/>
           <a:p>
-            <a:pPr indent="0" marL="0">
+            <a:pPr marL="0" indent="0">
               <a:lnSpc>
                 <a:spcPct val="105000"/>
               </a:lnSpc>
@@ -3734,9 +3599,9 @@
                 <a:solidFill>
                   <a:srgbClr val="94A3B8"/>
                 </a:solidFill>
-                <a:latin typeface="Arial" pitchFamily="34" charset="0"/>
-                <a:ea typeface="Arial" pitchFamily="34" charset="-122"/>
-                <a:cs typeface="Arial" pitchFamily="34" charset="-120"/>
+                <a:latin typeface="Arial" panose="020B0604020202020204" pitchFamily="34" charset="0"/>
+                <a:ea typeface="Arial" panose="020B0604020202020204" pitchFamily="34" charset="-122"/>
+                <a:cs typeface="Arial" panose="020B0604020202020204" pitchFamily="34" charset="-120"/>
               </a:rPr>
               <a:t>Desktop: chat and canvas split 50/50. Mobile: overlay.</a:t>
             </a:r>
@@ -3759,13 +3624,12 @@
             <a:avLst/>
           </a:prstGeom>
           <a:noFill/>
-          <a:ln/>
         </p:spPr>
         <p:txBody>
           <a:bodyPr wrap="square" rtlCol="0" anchor="ctr"/>
           <a:lstStyle/>
           <a:p>
-            <a:pPr indent="0" marL="0">
+            <a:pPr marL="0" indent="0">
               <a:buNone/>
             </a:pPr>
             <a:r>
@@ -3773,9 +3637,9 @@
                 <a:solidFill>
                   <a:srgbClr val="94A3B8"/>
                 </a:solidFill>
-                <a:latin typeface="Arial" pitchFamily="34" charset="0"/>
-                <a:ea typeface="Arial" pitchFamily="34" charset="-122"/>
-                <a:cs typeface="Arial" pitchFamily="34" charset="-120"/>
+                <a:latin typeface="Arial" panose="020B0604020202020204" pitchFamily="34" charset="0"/>
+                <a:ea typeface="Arial" panose="020B0604020202020204" pitchFamily="34" charset="-122"/>
+                <a:cs typeface="Arial" panose="020B0604020202020204" pitchFamily="34" charset="-120"/>
               </a:rPr>
               <a:t>StudyNotes+</a:t>
             </a:r>
@@ -3798,13 +3662,12 @@
             <a:avLst/>
           </a:prstGeom>
           <a:noFill/>
-          <a:ln/>
         </p:spPr>
         <p:txBody>
           <a:bodyPr wrap="square" rtlCol="0" anchor="ctr"/>
           <a:lstStyle/>
           <a:p>
-            <a:pPr algn="r" indent="0" marL="0">
+            <a:pPr marL="0" indent="0" algn="r">
               <a:buNone/>
             </a:pPr>
             <a:r>
@@ -3812,9 +3675,9 @@
                 <a:solidFill>
                   <a:srgbClr val="94A3B8"/>
                 </a:solidFill>
-                <a:latin typeface="Arial" pitchFamily="34" charset="0"/>
-                <a:ea typeface="Arial" pitchFamily="34" charset="-122"/>
-                <a:cs typeface="Arial" pitchFamily="34" charset="-120"/>
+                <a:latin typeface="Arial" panose="020B0604020202020204" pitchFamily="34" charset="0"/>
+                <a:ea typeface="Arial" panose="020B0604020202020204" pitchFamily="34" charset="-122"/>
+                <a:cs typeface="Arial" panose="020B0604020202020204" pitchFamily="34" charset="-120"/>
               </a:rPr>
               <a:t>3 / 7</a:t>
             </a:r>
@@ -3832,12 +3695,13 @@
 
 <file path=ppt/slides/slide4.xml><?xml version="1.0" encoding="utf-8"?>
 <p:sld xmlns:a="http://schemas.openxmlformats.org/drawingml/2006/main" xmlns:r="http://schemas.openxmlformats.org/officeDocument/2006/relationships" xmlns:p="http://schemas.openxmlformats.org/presentationml/2006/main">
-  <p:cSld name="Slide 4">
+  <p:cSld>
     <p:bg>
       <p:bgPr>
         <a:solidFill>
           <a:srgbClr val="0B1020"/>
         </a:solidFill>
+        <a:effectLst/>
       </p:bgPr>
     </p:bg>
     <p:spTree>
@@ -3873,7 +3737,6 @@
               <a:alpha val="18000"/>
             </a:srgbClr>
           </a:solidFill>
-          <a:ln/>
         </p:spPr>
       </p:sp>
       <p:sp>
@@ -3895,7 +3758,6 @@
               <a:alpha val="12000"/>
             </a:srgbClr>
           </a:solidFill>
-          <a:ln/>
         </p:spPr>
       </p:sp>
       <p:sp>
@@ -3917,7 +3779,6 @@
               <a:alpha val="10000"/>
             </a:srgbClr>
           </a:solidFill>
-          <a:ln/>
         </p:spPr>
       </p:sp>
       <p:sp>
@@ -3935,13 +3796,12 @@
             <a:avLst/>
           </a:prstGeom>
           <a:noFill/>
-          <a:ln/>
         </p:spPr>
         <p:txBody>
           <a:bodyPr wrap="square" rtlCol="0" anchor="ctr"/>
           <a:lstStyle/>
           <a:p>
-            <a:pPr indent="0" marL="0">
+            <a:pPr marL="0" indent="0">
               <a:buNone/>
             </a:pPr>
             <a:r>
@@ -3949,9 +3809,9 @@
                 <a:solidFill>
                   <a:srgbClr val="F8FAFC"/>
                 </a:solidFill>
-                <a:latin typeface="Arial" pitchFamily="34" charset="0"/>
-                <a:ea typeface="Arial" pitchFamily="34" charset="-122"/>
-                <a:cs typeface="Arial" pitchFamily="34" charset="-120"/>
+                <a:latin typeface="Arial" panose="020B0604020202020204" pitchFamily="34" charset="0"/>
+                <a:ea typeface="Arial" panose="020B0604020202020204" pitchFamily="34" charset="-122"/>
+                <a:cs typeface="Arial" panose="020B0604020202020204" pitchFamily="34" charset="-120"/>
               </a:rPr>
               <a:t>Live Demo Flow</a:t>
             </a:r>
@@ -3974,13 +3834,12 @@
             <a:avLst/>
           </a:prstGeom>
           <a:noFill/>
-          <a:ln/>
         </p:spPr>
         <p:txBody>
           <a:bodyPr wrap="square" rtlCol="0" anchor="ctr"/>
           <a:lstStyle/>
           <a:p>
-            <a:pPr indent="0" marL="0">
+            <a:pPr marL="0" indent="0">
               <a:buNone/>
             </a:pPr>
             <a:r>
@@ -3988,9 +3847,9 @@
                 <a:solidFill>
                   <a:srgbClr val="94A3B8"/>
                 </a:solidFill>
-                <a:latin typeface="Arial" pitchFamily="34" charset="0"/>
-                <a:ea typeface="Arial" pitchFamily="34" charset="-122"/>
-                <a:cs typeface="Arial" pitchFamily="34" charset="-120"/>
+                <a:latin typeface="Arial" panose="020B0604020202020204" pitchFamily="34" charset="0"/>
+                <a:ea typeface="Arial" panose="020B0604020202020204" pitchFamily="34" charset="-122"/>
+                <a:cs typeface="Arial" panose="020B0604020202020204" pitchFamily="34" charset="-120"/>
               </a:rPr>
               <a:t>Five clicks from sign-in to a personalized, versioned revision doc.</a:t>
             </a:r>
@@ -4017,7 +3876,6 @@
           <a:solidFill>
             <a:srgbClr val="F59E0B"/>
           </a:solidFill>
-          <a:ln/>
         </p:spPr>
       </p:sp>
       <p:sp>
@@ -4037,7 +3895,6 @@
           <a:solidFill>
             <a:srgbClr val="6366F1"/>
           </a:solidFill>
-          <a:ln/>
         </p:spPr>
       </p:sp>
       <p:sp>
@@ -4055,13 +3912,12 @@
             <a:avLst/>
           </a:prstGeom>
           <a:noFill/>
-          <a:ln/>
         </p:spPr>
         <p:txBody>
           <a:bodyPr wrap="square" rtlCol="0" anchor="ctr"/>
           <a:lstStyle/>
           <a:p>
-            <a:pPr algn="ctr" indent="0" marL="0">
+            <a:pPr marL="0" indent="0" algn="ctr">
               <a:buNone/>
             </a:pPr>
             <a:r>
@@ -4069,9 +3925,9 @@
                 <a:solidFill>
                   <a:srgbClr val="FFFFFF"/>
                 </a:solidFill>
-                <a:latin typeface="Arial" pitchFamily="34" charset="0"/>
-                <a:ea typeface="Arial" pitchFamily="34" charset="-122"/>
-                <a:cs typeface="Arial" pitchFamily="34" charset="-120"/>
+                <a:latin typeface="Arial" panose="020B0604020202020204" pitchFamily="34" charset="0"/>
+                <a:ea typeface="Arial" panose="020B0604020202020204" pitchFamily="34" charset="-122"/>
+                <a:cs typeface="Arial" panose="020B0604020202020204" pitchFamily="34" charset="-120"/>
               </a:rPr>
               <a:t>1</a:t>
             </a:r>
@@ -4094,13 +3950,12 @@
             <a:avLst/>
           </a:prstGeom>
           <a:noFill/>
-          <a:ln/>
         </p:spPr>
         <p:txBody>
           <a:bodyPr wrap="square" rtlCol="0" anchor="ctr"/>
           <a:lstStyle/>
           <a:p>
-            <a:pPr indent="0" marL="0">
+            <a:pPr marL="0" indent="0">
               <a:buNone/>
             </a:pPr>
             <a:r>
@@ -4108,9 +3963,9 @@
                 <a:solidFill>
                   <a:srgbClr val="F8FAFC"/>
                 </a:solidFill>
-                <a:latin typeface="Arial" pitchFamily="34" charset="0"/>
-                <a:ea typeface="Arial" pitchFamily="34" charset="-122"/>
-                <a:cs typeface="Arial" pitchFamily="34" charset="-120"/>
+                <a:latin typeface="Arial" panose="020B0604020202020204" pitchFamily="34" charset="0"/>
+                <a:ea typeface="Arial" panose="020B0604020202020204" pitchFamily="34" charset="-122"/>
+                <a:cs typeface="Arial" panose="020B0604020202020204" pitchFamily="34" charset="-120"/>
               </a:rPr>
               <a:t>Sign in → pick Mathematics → choose a chapter</a:t>
             </a:r>
@@ -4158,7 +4013,6 @@
           <a:solidFill>
             <a:srgbClr val="F59E0B"/>
           </a:solidFill>
-          <a:ln/>
         </p:spPr>
       </p:sp>
       <p:sp>
@@ -4176,13 +4030,12 @@
             <a:avLst/>
           </a:prstGeom>
           <a:noFill/>
-          <a:ln/>
         </p:spPr>
         <p:txBody>
           <a:bodyPr wrap="square" rtlCol="0" anchor="ctr"/>
           <a:lstStyle/>
           <a:p>
-            <a:pPr algn="ctr" indent="0" marL="0">
+            <a:pPr marL="0" indent="0" algn="ctr">
               <a:buNone/>
             </a:pPr>
             <a:r>
@@ -4190,9 +4043,9 @@
                 <a:solidFill>
                   <a:srgbClr val="FFFFFF"/>
                 </a:solidFill>
-                <a:latin typeface="Arial" pitchFamily="34" charset="0"/>
-                <a:ea typeface="Arial" pitchFamily="34" charset="-122"/>
-                <a:cs typeface="Arial" pitchFamily="34" charset="-120"/>
+                <a:latin typeface="Arial" panose="020B0604020202020204" pitchFamily="34" charset="0"/>
+                <a:ea typeface="Arial" panose="020B0604020202020204" pitchFamily="34" charset="-122"/>
+                <a:cs typeface="Arial" panose="020B0604020202020204" pitchFamily="34" charset="-120"/>
               </a:rPr>
               <a:t>2</a:t>
             </a:r>
@@ -4215,13 +4068,12 @@
             <a:avLst/>
           </a:prstGeom>
           <a:noFill/>
-          <a:ln/>
         </p:spPr>
         <p:txBody>
           <a:bodyPr wrap="square" rtlCol="0" anchor="ctr"/>
           <a:lstStyle/>
           <a:p>
-            <a:pPr indent="0" marL="0">
+            <a:pPr marL="0" indent="0">
               <a:buNone/>
             </a:pPr>
             <a:r>
@@ -4229,9 +4081,9 @@
                 <a:solidFill>
                   <a:srgbClr val="F8FAFC"/>
                 </a:solidFill>
-                <a:latin typeface="Arial" pitchFamily="34" charset="0"/>
-                <a:ea typeface="Arial" pitchFamily="34" charset="-122"/>
-                <a:cs typeface="Arial" pitchFamily="34" charset="-120"/>
+                <a:latin typeface="Arial" panose="020B0604020202020204" pitchFamily="34" charset="0"/>
+                <a:ea typeface="Arial" panose="020B0604020202020204" pitchFamily="34" charset="-122"/>
+                <a:cs typeface="Arial" panose="020B0604020202020204" pitchFamily="34" charset="-120"/>
               </a:rPr>
               <a:t>Ask in Explain mode → see a cited, NCERT-grounded answer</a:t>
             </a:r>
@@ -4279,7 +4131,6 @@
           <a:solidFill>
             <a:srgbClr val="6366F1"/>
           </a:solidFill>
-          <a:ln/>
         </p:spPr>
       </p:sp>
       <p:sp>
@@ -4297,13 +4148,12 @@
             <a:avLst/>
           </a:prstGeom>
           <a:noFill/>
-          <a:ln/>
         </p:spPr>
         <p:txBody>
           <a:bodyPr wrap="square" rtlCol="0" anchor="ctr"/>
           <a:lstStyle/>
           <a:p>
-            <a:pPr algn="ctr" indent="0" marL="0">
+            <a:pPr marL="0" indent="0" algn="ctr">
               <a:buNone/>
             </a:pPr>
             <a:r>
@@ -4311,9 +4161,9 @@
                 <a:solidFill>
                   <a:srgbClr val="FFFFFF"/>
                 </a:solidFill>
-                <a:latin typeface="Arial" pitchFamily="34" charset="0"/>
-                <a:ea typeface="Arial" pitchFamily="34" charset="-122"/>
-                <a:cs typeface="Arial" pitchFamily="34" charset="-120"/>
+                <a:latin typeface="Arial" panose="020B0604020202020204" pitchFamily="34" charset="0"/>
+                <a:ea typeface="Arial" panose="020B0604020202020204" pitchFamily="34" charset="-122"/>
+                <a:cs typeface="Arial" panose="020B0604020202020204" pitchFamily="34" charset="-120"/>
               </a:rPr>
               <a:t>3</a:t>
             </a:r>
@@ -4336,13 +4186,12 @@
             <a:avLst/>
           </a:prstGeom>
           <a:noFill/>
-          <a:ln/>
         </p:spPr>
         <p:txBody>
           <a:bodyPr wrap="square" rtlCol="0" anchor="ctr"/>
           <a:lstStyle/>
           <a:p>
-            <a:pPr indent="0" marL="0">
+            <a:pPr marL="0" indent="0">
               <a:buNone/>
             </a:pPr>
             <a:r>
@@ -4350,9 +4199,9 @@
                 <a:solidFill>
                   <a:srgbClr val="F8FAFC"/>
                 </a:solidFill>
-                <a:latin typeface="Arial" pitchFamily="34" charset="0"/>
-                <a:ea typeface="Arial" pitchFamily="34" charset="-122"/>
-                <a:cs typeface="Arial" pitchFamily="34" charset="-120"/>
+                <a:latin typeface="Arial" panose="020B0604020202020204" pitchFamily="34" charset="0"/>
+                <a:ea typeface="Arial" panose="020B0604020202020204" pitchFamily="34" charset="-122"/>
+                <a:cs typeface="Arial" panose="020B0604020202020204" pitchFamily="34" charset="-120"/>
               </a:rPr>
               <a:t>Switch to Generate Notes → AI streams a structured doc into the canvas</a:t>
             </a:r>
@@ -4400,7 +4249,6 @@
           <a:solidFill>
             <a:srgbClr val="F59E0B"/>
           </a:solidFill>
-          <a:ln/>
         </p:spPr>
       </p:sp>
       <p:sp>
@@ -4418,13 +4266,12 @@
             <a:avLst/>
           </a:prstGeom>
           <a:noFill/>
-          <a:ln/>
         </p:spPr>
         <p:txBody>
           <a:bodyPr wrap="square" rtlCol="0" anchor="ctr"/>
           <a:lstStyle/>
           <a:p>
-            <a:pPr algn="ctr" indent="0" marL="0">
+            <a:pPr marL="0" indent="0" algn="ctr">
               <a:buNone/>
             </a:pPr>
             <a:r>
@@ -4432,9 +4279,9 @@
                 <a:solidFill>
                   <a:srgbClr val="FFFFFF"/>
                 </a:solidFill>
-                <a:latin typeface="Arial" pitchFamily="34" charset="0"/>
-                <a:ea typeface="Arial" pitchFamily="34" charset="-122"/>
-                <a:cs typeface="Arial" pitchFamily="34" charset="-120"/>
+                <a:latin typeface="Arial" panose="020B0604020202020204" pitchFamily="34" charset="0"/>
+                <a:ea typeface="Arial" panose="020B0604020202020204" pitchFamily="34" charset="-122"/>
+                <a:cs typeface="Arial" panose="020B0604020202020204" pitchFamily="34" charset="-120"/>
               </a:rPr>
               <a:t>4</a:t>
             </a:r>
@@ -4457,13 +4304,12 @@
             <a:avLst/>
           </a:prstGeom>
           <a:noFill/>
-          <a:ln/>
         </p:spPr>
         <p:txBody>
           <a:bodyPr wrap="square" rtlCol="0" anchor="ctr"/>
           <a:lstStyle/>
           <a:p>
-            <a:pPr indent="0" marL="0">
+            <a:pPr marL="0" indent="0">
               <a:buNone/>
             </a:pPr>
             <a:r>
@@ -4471,9 +4317,9 @@
                 <a:solidFill>
                   <a:srgbClr val="F8FAFC"/>
                 </a:solidFill>
-                <a:latin typeface="Arial" pitchFamily="34" charset="0"/>
-                <a:ea typeface="Arial" pitchFamily="34" charset="-122"/>
-                <a:cs typeface="Arial" pitchFamily="34" charset="-120"/>
+                <a:latin typeface="Arial" panose="020B0604020202020204" pitchFamily="34" charset="0"/>
+                <a:ea typeface="Arial" panose="020B0604020202020204" pitchFamily="34" charset="-122"/>
+                <a:cs typeface="Arial" panose="020B0604020202020204" pitchFamily="34" charset="-120"/>
               </a:rPr>
               <a:t>Type: "highlight the main points in green" → AI edits only that, keeps the rest</a:t>
             </a:r>
@@ -4521,7 +4367,6 @@
           <a:solidFill>
             <a:srgbClr val="6366F1"/>
           </a:solidFill>
-          <a:ln/>
         </p:spPr>
       </p:sp>
       <p:sp>
@@ -4539,13 +4384,12 @@
             <a:avLst/>
           </a:prstGeom>
           <a:noFill/>
-          <a:ln/>
         </p:spPr>
         <p:txBody>
           <a:bodyPr wrap="square" rtlCol="0" anchor="ctr"/>
           <a:lstStyle/>
           <a:p>
-            <a:pPr algn="ctr" indent="0" marL="0">
+            <a:pPr marL="0" indent="0" algn="ctr">
               <a:buNone/>
             </a:pPr>
             <a:r>
@@ -4553,9 +4397,9 @@
                 <a:solidFill>
                   <a:srgbClr val="FFFFFF"/>
                 </a:solidFill>
-                <a:latin typeface="Arial" pitchFamily="34" charset="0"/>
-                <a:ea typeface="Arial" pitchFamily="34" charset="-122"/>
-                <a:cs typeface="Arial" pitchFamily="34" charset="-120"/>
+                <a:latin typeface="Arial" panose="020B0604020202020204" pitchFamily="34" charset="0"/>
+                <a:ea typeface="Arial" panose="020B0604020202020204" pitchFamily="34" charset="-122"/>
+                <a:cs typeface="Arial" panose="020B0604020202020204" pitchFamily="34" charset="-120"/>
               </a:rPr>
               <a:t>5</a:t>
             </a:r>
@@ -4578,13 +4422,12 @@
             <a:avLst/>
           </a:prstGeom>
           <a:noFill/>
-          <a:ln/>
         </p:spPr>
         <p:txBody>
           <a:bodyPr wrap="square" rtlCol="0" anchor="ctr"/>
           <a:lstStyle/>
           <a:p>
-            <a:pPr indent="0" marL="0">
+            <a:pPr marL="0" indent="0">
               <a:buNone/>
             </a:pPr>
             <a:r>
@@ -4592,9 +4435,9 @@
                 <a:solidFill>
                   <a:srgbClr val="F8FAFC"/>
                 </a:solidFill>
-                <a:latin typeface="Arial" pitchFamily="34" charset="0"/>
-                <a:ea typeface="Arial" pitchFamily="34" charset="-122"/>
-                <a:cs typeface="Arial" pitchFamily="34" charset="-120"/>
+                <a:latin typeface="Arial" panose="020B0604020202020204" pitchFamily="34" charset="0"/>
+                <a:ea typeface="Arial" panose="020B0604020202020204" pitchFamily="34" charset="-122"/>
+                <a:cs typeface="Arial" panose="020B0604020202020204" pitchFamily="34" charset="-120"/>
               </a:rPr>
               <a:t>Undo / refresh → your notes and full revision history are still there</a:t>
             </a:r>
@@ -4617,13 +4460,12 @@
             <a:avLst/>
           </a:prstGeom>
           <a:noFill/>
-          <a:ln/>
         </p:spPr>
         <p:txBody>
           <a:bodyPr wrap="square" rtlCol="0" anchor="ctr"/>
           <a:lstStyle/>
           <a:p>
-            <a:pPr indent="0" marL="0">
+            <a:pPr marL="0" indent="0">
               <a:buNone/>
             </a:pPr>
             <a:r>
@@ -4631,9 +4473,9 @@
                 <a:solidFill>
                   <a:srgbClr val="94A3B8"/>
                 </a:solidFill>
-                <a:latin typeface="Arial" pitchFamily="34" charset="0"/>
-                <a:ea typeface="Arial" pitchFamily="34" charset="-122"/>
-                <a:cs typeface="Arial" pitchFamily="34" charset="-120"/>
+                <a:latin typeface="Arial" panose="020B0604020202020204" pitchFamily="34" charset="0"/>
+                <a:ea typeface="Arial" panose="020B0604020202020204" pitchFamily="34" charset="-122"/>
+                <a:cs typeface="Arial" panose="020B0604020202020204" pitchFamily="34" charset="-120"/>
               </a:rPr>
               <a:t>StudyNotes+</a:t>
             </a:r>
@@ -4656,13 +4498,12 @@
             <a:avLst/>
           </a:prstGeom>
           <a:noFill/>
-          <a:ln/>
         </p:spPr>
         <p:txBody>
           <a:bodyPr wrap="square" rtlCol="0" anchor="ctr"/>
           <a:lstStyle/>
           <a:p>
-            <a:pPr algn="r" indent="0" marL="0">
+            <a:pPr marL="0" indent="0" algn="r">
               <a:buNone/>
             </a:pPr>
             <a:r>
@@ -4670,9 +4511,9 @@
                 <a:solidFill>
                   <a:srgbClr val="94A3B8"/>
                 </a:solidFill>
-                <a:latin typeface="Arial" pitchFamily="34" charset="0"/>
-                <a:ea typeface="Arial" pitchFamily="34" charset="-122"/>
-                <a:cs typeface="Arial" pitchFamily="34" charset="-120"/>
+                <a:latin typeface="Arial" panose="020B0604020202020204" pitchFamily="34" charset="0"/>
+                <a:ea typeface="Arial" panose="020B0604020202020204" pitchFamily="34" charset="-122"/>
+                <a:cs typeface="Arial" panose="020B0604020202020204" pitchFamily="34" charset="-120"/>
               </a:rPr>
               <a:t>4 / 7</a:t>
             </a:r>
@@ -4690,12 +4531,13 @@
 
 <file path=ppt/slides/slide5.xml><?xml version="1.0" encoding="utf-8"?>
 <p:sld xmlns:a="http://schemas.openxmlformats.org/drawingml/2006/main" xmlns:r="http://schemas.openxmlformats.org/officeDocument/2006/relationships" xmlns:p="http://schemas.openxmlformats.org/presentationml/2006/main">
-  <p:cSld name="Slide 5">
+  <p:cSld>
     <p:bg>
       <p:bgPr>
         <a:solidFill>
           <a:srgbClr val="0B1020"/>
         </a:solidFill>
+        <a:effectLst/>
       </p:bgPr>
     </p:bg>
     <p:spTree>
@@ -4731,7 +4573,6 @@
               <a:alpha val="18000"/>
             </a:srgbClr>
           </a:solidFill>
-          <a:ln/>
         </p:spPr>
       </p:sp>
       <p:sp>
@@ -4753,7 +4594,6 @@
               <a:alpha val="12000"/>
             </a:srgbClr>
           </a:solidFill>
-          <a:ln/>
         </p:spPr>
       </p:sp>
       <p:sp>
@@ -4775,7 +4615,6 @@
               <a:alpha val="10000"/>
             </a:srgbClr>
           </a:solidFill>
-          <a:ln/>
         </p:spPr>
       </p:sp>
       <p:sp>
@@ -4793,13 +4632,12 @@
             <a:avLst/>
           </a:prstGeom>
           <a:noFill/>
-          <a:ln/>
         </p:spPr>
         <p:txBody>
           <a:bodyPr wrap="square" rtlCol="0" anchor="ctr"/>
           <a:lstStyle/>
           <a:p>
-            <a:pPr indent="0" marL="0">
+            <a:pPr marL="0" indent="0">
               <a:buNone/>
             </a:pPr>
             <a:r>
@@ -4807,9 +4645,9 @@
                 <a:solidFill>
                   <a:srgbClr val="F8FAFC"/>
                 </a:solidFill>
-                <a:latin typeface="Arial" pitchFamily="34" charset="0"/>
-                <a:ea typeface="Arial" pitchFamily="34" charset="-122"/>
-                <a:cs typeface="Arial" pitchFamily="34" charset="-120"/>
+                <a:latin typeface="Arial" panose="020B0604020202020204" pitchFamily="34" charset="0"/>
+                <a:ea typeface="Arial" panose="020B0604020202020204" pitchFamily="34" charset="-122"/>
+                <a:cs typeface="Arial" panose="020B0604020202020204" pitchFamily="34" charset="-120"/>
               </a:rPr>
               <a:t>How It Works</a:t>
             </a:r>
@@ -4832,13 +4670,12 @@
             <a:avLst/>
           </a:prstGeom>
           <a:noFill/>
-          <a:ln/>
         </p:spPr>
         <p:txBody>
           <a:bodyPr wrap="square" rtlCol="0" anchor="ctr"/>
           <a:lstStyle/>
           <a:p>
-            <a:pPr indent="0" marL="0">
+            <a:pPr marL="0" indent="0">
               <a:buNone/>
             </a:pPr>
             <a:r>
@@ -4846,9 +4683,9 @@
                 <a:solidFill>
                   <a:srgbClr val="94A3B8"/>
                 </a:solidFill>
-                <a:latin typeface="Arial" pitchFamily="34" charset="0"/>
-                <a:ea typeface="Arial" pitchFamily="34" charset="-122"/>
-                <a:cs typeface="Arial" pitchFamily="34" charset="-120"/>
+                <a:latin typeface="Arial" panose="020B0604020202020204" pitchFamily="34" charset="0"/>
+                <a:ea typeface="Arial" panose="020B0604020202020204" pitchFamily="34" charset="-122"/>
+                <a:cs typeface="Arial" panose="020B0604020202020204" pitchFamily="34" charset="-120"/>
               </a:rPr>
               <a:t>A streaming, retrieval-augmented pipeline with a strict ownership boundary.</a:t>
             </a:r>
@@ -4875,7 +4712,6 @@
           <a:solidFill>
             <a:srgbClr val="F59E0B"/>
           </a:solidFill>
-          <a:ln/>
         </p:spPr>
       </p:sp>
       <p:sp>
@@ -4895,7 +4731,6 @@
           <a:solidFill>
             <a:srgbClr val="6366F1"/>
           </a:solidFill>
-          <a:ln/>
         </p:spPr>
       </p:sp>
       <p:sp>
@@ -4913,13 +4748,12 @@
             <a:avLst/>
           </a:prstGeom>
           <a:noFill/>
-          <a:ln/>
         </p:spPr>
         <p:txBody>
           <a:bodyPr wrap="square" rtlCol="0" anchor="t"/>
           <a:lstStyle/>
           <a:p>
-            <a:pPr indent="0" marL="0">
+            <a:pPr marL="0" indent="0">
               <a:lnSpc>
                 <a:spcPct val="105000"/>
               </a:lnSpc>
@@ -4930,9 +4764,9 @@
                 <a:solidFill>
                   <a:srgbClr val="F8FAFC"/>
                 </a:solidFill>
-                <a:latin typeface="Arial" pitchFamily="34" charset="0"/>
-                <a:ea typeface="Arial" pitchFamily="34" charset="-122"/>
-                <a:cs typeface="Arial" pitchFamily="34" charset="-120"/>
+                <a:latin typeface="Arial" panose="020B0604020202020204" pitchFamily="34" charset="0"/>
+                <a:ea typeface="Arial" panose="020B0604020202020204" pitchFamily="34" charset="-122"/>
+                <a:cs typeface="Arial" panose="020B0604020202020204" pitchFamily="34" charset="-120"/>
               </a:rPr>
               <a:t>Frontend: Next.js 16 (App Router) + React 19 + TypeScript, streamed over SSE</a:t>
             </a:r>
@@ -4957,7 +4791,6 @@
           <a:solidFill>
             <a:srgbClr val="F59E0B"/>
           </a:solidFill>
-          <a:ln/>
         </p:spPr>
       </p:sp>
       <p:sp>
@@ -4975,13 +4808,12 @@
             <a:avLst/>
           </a:prstGeom>
           <a:noFill/>
-          <a:ln/>
         </p:spPr>
         <p:txBody>
           <a:bodyPr wrap="square" rtlCol="0" anchor="t"/>
           <a:lstStyle/>
           <a:p>
-            <a:pPr indent="0" marL="0">
+            <a:pPr marL="0" indent="0">
               <a:lnSpc>
                 <a:spcPct val="105000"/>
               </a:lnSpc>
@@ -4992,9 +4824,9 @@
                 <a:solidFill>
                   <a:srgbClr val="F8FAFC"/>
                 </a:solidFill>
-                <a:latin typeface="Arial" pitchFamily="34" charset="0"/>
-                <a:ea typeface="Arial" pitchFamily="34" charset="-122"/>
-                <a:cs typeface="Arial" pitchFamily="34" charset="-120"/>
+                <a:latin typeface="Arial" panose="020B0604020202020204" pitchFamily="34" charset="0"/>
+                <a:ea typeface="Arial" panose="020B0604020202020204" pitchFamily="34" charset="-122"/>
+                <a:cs typeface="Arial" panose="020B0604020202020204" pitchFamily="34" charset="-120"/>
               </a:rPr>
               <a:t>Retrieval: Qdrant vector DB + OpenAI embeddings over approved NCERT chunks</a:t>
             </a:r>
@@ -5019,7 +4851,6 @@
           <a:solidFill>
             <a:srgbClr val="6366F1"/>
           </a:solidFill>
-          <a:ln/>
         </p:spPr>
       </p:sp>
       <p:sp>
@@ -5037,13 +4868,12 @@
             <a:avLst/>
           </a:prstGeom>
           <a:noFill/>
-          <a:ln/>
         </p:spPr>
         <p:txBody>
           <a:bodyPr wrap="square" rtlCol="0" anchor="t"/>
           <a:lstStyle/>
           <a:p>
-            <a:pPr indent="0" marL="0">
+            <a:pPr marL="0" indent="0">
               <a:lnSpc>
                 <a:spcPct val="105000"/>
               </a:lnSpc>
@@ -5054,9 +4884,9 @@
                 <a:solidFill>
                   <a:srgbClr val="F8FAFC"/>
                 </a:solidFill>
-                <a:latin typeface="Arial" pitchFamily="34" charset="0"/>
-                <a:ea typeface="Arial" pitchFamily="34" charset="-122"/>
-                <a:cs typeface="Arial" pitchFamily="34" charset="-120"/>
+                <a:latin typeface="Arial" panose="020B0604020202020204" pitchFamily="34" charset="0"/>
+                <a:ea typeface="Arial" panose="020B0604020202020204" pitchFamily="34" charset="-122"/>
+                <a:cs typeface="Arial" panose="020B0604020202020204" pitchFamily="34" charset="-120"/>
               </a:rPr>
               <a:t>LLM: OpenAI chat / reasoning / moderation models, token-streamed to the UI</a:t>
             </a:r>
@@ -5081,7 +4911,6 @@
           <a:solidFill>
             <a:srgbClr val="F59E0B"/>
           </a:solidFill>
-          <a:ln/>
         </p:spPr>
       </p:sp>
       <p:sp>
@@ -5099,13 +4928,12 @@
             <a:avLst/>
           </a:prstGeom>
           <a:noFill/>
-          <a:ln/>
         </p:spPr>
         <p:txBody>
           <a:bodyPr wrap="square" rtlCol="0" anchor="t"/>
           <a:lstStyle/>
           <a:p>
-            <a:pPr indent="0" marL="0">
+            <a:pPr marL="0" indent="0">
               <a:lnSpc>
                 <a:spcPct val="105000"/>
               </a:lnSpc>
@@ -5116,9 +4944,9 @@
                 <a:solidFill>
                   <a:srgbClr val="F8FAFC"/>
                 </a:solidFill>
-                <a:latin typeface="Arial" pitchFamily="34" charset="0"/>
-                <a:ea typeface="Arial" pitchFamily="34" charset="-122"/>
-                <a:cs typeface="Arial" pitchFamily="34" charset="-120"/>
+                <a:latin typeface="Arial" panose="020B0604020202020204" pitchFamily="34" charset="0"/>
+                <a:ea typeface="Arial" panose="020B0604020202020204" pitchFamily="34" charset="-122"/>
+                <a:cs typeface="Arial" panose="020B0604020202020204" pitchFamily="34" charset="-120"/>
               </a:rPr>
               <a:t>Data: Neon PostgreSQL — tenants, conversations, note documents + versions</a:t>
             </a:r>
@@ -5143,7 +4971,6 @@
           <a:solidFill>
             <a:srgbClr val="6366F1"/>
           </a:solidFill>
-          <a:ln/>
         </p:spPr>
       </p:sp>
       <p:sp>
@@ -5161,13 +4988,12 @@
             <a:avLst/>
           </a:prstGeom>
           <a:noFill/>
-          <a:ln/>
         </p:spPr>
         <p:txBody>
           <a:bodyPr wrap="square" rtlCol="0" anchor="t"/>
           <a:lstStyle/>
           <a:p>
-            <a:pPr indent="0" marL="0">
+            <a:pPr marL="0" indent="0">
               <a:lnSpc>
                 <a:spcPct val="105000"/>
               </a:lnSpc>
@@ -5178,9 +5004,9 @@
                 <a:solidFill>
                   <a:srgbClr val="F8FAFC"/>
                 </a:solidFill>
-                <a:latin typeface="Arial" pitchFamily="34" charset="0"/>
-                <a:ea typeface="Arial" pitchFamily="34" charset="-122"/>
-                <a:cs typeface="Arial" pitchFamily="34" charset="-120"/>
+                <a:latin typeface="Arial" panose="020B0604020202020204" pitchFamily="34" charset="0"/>
+                <a:ea typeface="Arial" panose="020B0604020202020204" pitchFamily="34" charset="-122"/>
+                <a:cs typeface="Arial" panose="020B0604020202020204" pitchFamily="34" charset="-120"/>
               </a:rPr>
               <a:t>Safety &amp; scale: Clerk auth, Upstash Redis rate limiting, Sentry, moderation</a:t>
             </a:r>
@@ -5205,7 +5031,6 @@
           <a:solidFill>
             <a:srgbClr val="F59E0B"/>
           </a:solidFill>
-          <a:ln/>
         </p:spPr>
       </p:sp>
       <p:sp>
@@ -5223,13 +5048,12 @@
             <a:avLst/>
           </a:prstGeom>
           <a:noFill/>
-          <a:ln/>
         </p:spPr>
         <p:txBody>
           <a:bodyPr wrap="square" rtlCol="0" anchor="t"/>
           <a:lstStyle/>
           <a:p>
-            <a:pPr indent="0" marL="0">
+            <a:pPr marL="0" indent="0">
               <a:lnSpc>
                 <a:spcPct val="105000"/>
               </a:lnSpc>
@@ -5240,9 +5064,9 @@
                 <a:solidFill>
                   <a:srgbClr val="F8FAFC"/>
                 </a:solidFill>
-                <a:latin typeface="Arial" pitchFamily="34" charset="0"/>
-                <a:ea typeface="Arial" pitchFamily="34" charset="-122"/>
-                <a:cs typeface="Arial" pitchFamily="34" charset="-120"/>
+                <a:latin typeface="Arial" panose="020B0604020202020204" pitchFamily="34" charset="0"/>
+                <a:ea typeface="Arial" panose="020B0604020202020204" pitchFamily="34" charset="-122"/>
+                <a:cs typeface="Arial" panose="020B0604020202020204" pitchFamily="34" charset="-120"/>
               </a:rPr>
               <a:t>Ownership: every query scoped by user_id + tenant_id — students see only their workspace</a:t>
             </a:r>
@@ -5265,13 +5089,12 @@
             <a:avLst/>
           </a:prstGeom>
           <a:noFill/>
-          <a:ln/>
         </p:spPr>
         <p:txBody>
           <a:bodyPr wrap="square" rtlCol="0" anchor="ctr"/>
           <a:lstStyle/>
           <a:p>
-            <a:pPr indent="0" marL="0">
+            <a:pPr marL="0" indent="0">
               <a:buNone/>
             </a:pPr>
             <a:r>
@@ -5279,9 +5102,9 @@
                 <a:solidFill>
                   <a:srgbClr val="94A3B8"/>
                 </a:solidFill>
-                <a:latin typeface="Arial" pitchFamily="34" charset="0"/>
-                <a:ea typeface="Arial" pitchFamily="34" charset="-122"/>
-                <a:cs typeface="Arial" pitchFamily="34" charset="-120"/>
+                <a:latin typeface="Arial" panose="020B0604020202020204" pitchFamily="34" charset="0"/>
+                <a:ea typeface="Arial" panose="020B0604020202020204" pitchFamily="34" charset="-122"/>
+                <a:cs typeface="Arial" panose="020B0604020202020204" pitchFamily="34" charset="-120"/>
               </a:rPr>
               <a:t>StudyNotes+</a:t>
             </a:r>
@@ -5304,13 +5127,12 @@
             <a:avLst/>
           </a:prstGeom>
           <a:noFill/>
-          <a:ln/>
         </p:spPr>
         <p:txBody>
           <a:bodyPr wrap="square" rtlCol="0" anchor="ctr"/>
           <a:lstStyle/>
           <a:p>
-            <a:pPr algn="r" indent="0" marL="0">
+            <a:pPr marL="0" indent="0" algn="r">
               <a:buNone/>
             </a:pPr>
             <a:r>
@@ -5318,9 +5140,9 @@
                 <a:solidFill>
                   <a:srgbClr val="94A3B8"/>
                 </a:solidFill>
-                <a:latin typeface="Arial" pitchFamily="34" charset="0"/>
-                <a:ea typeface="Arial" pitchFamily="34" charset="-122"/>
-                <a:cs typeface="Arial" pitchFamily="34" charset="-120"/>
+                <a:latin typeface="Arial" panose="020B0604020202020204" pitchFamily="34" charset="0"/>
+                <a:ea typeface="Arial" panose="020B0604020202020204" pitchFamily="34" charset="-122"/>
+                <a:cs typeface="Arial" panose="020B0604020202020204" pitchFamily="34" charset="-120"/>
               </a:rPr>
               <a:t>5 / 7</a:t>
             </a:r>
@@ -5338,12 +5160,13 @@
 
 <file path=ppt/slides/slide6.xml><?xml version="1.0" encoding="utf-8"?>
 <p:sld xmlns:a="http://schemas.openxmlformats.org/drawingml/2006/main" xmlns:r="http://schemas.openxmlformats.org/officeDocument/2006/relationships" xmlns:p="http://schemas.openxmlformats.org/presentationml/2006/main">
-  <p:cSld name="Slide 6">
+  <p:cSld>
     <p:bg>
       <p:bgPr>
         <a:solidFill>
           <a:srgbClr val="0B1020"/>
         </a:solidFill>
+        <a:effectLst/>
       </p:bgPr>
     </p:bg>
     <p:spTree>
@@ -5379,7 +5202,6 @@
               <a:alpha val="18000"/>
             </a:srgbClr>
           </a:solidFill>
-          <a:ln/>
         </p:spPr>
       </p:sp>
       <p:sp>
@@ -5401,7 +5223,6 @@
               <a:alpha val="12000"/>
             </a:srgbClr>
           </a:solidFill>
-          <a:ln/>
         </p:spPr>
       </p:sp>
       <p:sp>
@@ -5423,7 +5244,6 @@
               <a:alpha val="10000"/>
             </a:srgbClr>
           </a:solidFill>
-          <a:ln/>
         </p:spPr>
       </p:sp>
       <p:sp>
@@ -5441,13 +5261,12 @@
             <a:avLst/>
           </a:prstGeom>
           <a:noFill/>
-          <a:ln/>
         </p:spPr>
         <p:txBody>
           <a:bodyPr wrap="square" rtlCol="0" anchor="ctr"/>
           <a:lstStyle/>
           <a:p>
-            <a:pPr indent="0" marL="0">
+            <a:pPr marL="0" indent="0">
               <a:buNone/>
             </a:pPr>
             <a:r>
@@ -5455,9 +5274,9 @@
                 <a:solidFill>
                   <a:srgbClr val="F8FAFC"/>
                 </a:solidFill>
-                <a:latin typeface="Arial" pitchFamily="34" charset="0"/>
-                <a:ea typeface="Arial" pitchFamily="34" charset="-122"/>
-                <a:cs typeface="Arial" pitchFamily="34" charset="-120"/>
+                <a:latin typeface="Arial" panose="020B0604020202020204" pitchFamily="34" charset="0"/>
+                <a:ea typeface="Arial" panose="020B0604020202020204" pitchFamily="34" charset="-122"/>
+                <a:cs typeface="Arial" panose="020B0604020202020204" pitchFamily="34" charset="-120"/>
               </a:rPr>
               <a:t>Safe &amp; Robust by Design</a:t>
             </a:r>
@@ -5480,13 +5299,12 @@
             <a:avLst/>
           </a:prstGeom>
           <a:noFill/>
-          <a:ln/>
         </p:spPr>
         <p:txBody>
           <a:bodyPr wrap="square" rtlCol="0" anchor="ctr"/>
           <a:lstStyle/>
           <a:p>
-            <a:pPr indent="0" marL="0">
+            <a:pPr marL="0" indent="0">
               <a:buNone/>
             </a:pPr>
             <a:r>
@@ -5494,9 +5312,9 @@
                 <a:solidFill>
                   <a:srgbClr val="94A3B8"/>
                 </a:solidFill>
-                <a:latin typeface="Arial" pitchFamily="34" charset="0"/>
-                <a:ea typeface="Arial" pitchFamily="34" charset="-122"/>
-                <a:cs typeface="Arial" pitchFamily="34" charset="-120"/>
+                <a:latin typeface="Arial" panose="020B0604020202020204" pitchFamily="34" charset="0"/>
+                <a:ea typeface="Arial" panose="020B0604020202020204" pitchFamily="34" charset="-122"/>
+                <a:cs typeface="Arial" panose="020B0604020202020204" pitchFamily="34" charset="-120"/>
               </a:rPr>
               <a:t>Engineered for failure modes, not just happy paths.</a:t>
             </a:r>
@@ -5523,7 +5341,6 @@
           <a:solidFill>
             <a:srgbClr val="F59E0B"/>
           </a:solidFill>
-          <a:ln/>
         </p:spPr>
       </p:sp>
       <p:sp>
@@ -5543,7 +5360,6 @@
           <a:solidFill>
             <a:srgbClr val="6366F1"/>
           </a:solidFill>
-          <a:ln/>
         </p:spPr>
       </p:sp>
       <p:sp>
@@ -5561,13 +5377,12 @@
             <a:avLst/>
           </a:prstGeom>
           <a:noFill/>
-          <a:ln/>
         </p:spPr>
         <p:txBody>
           <a:bodyPr wrap="square" rtlCol="0" anchor="t"/>
           <a:lstStyle/>
           <a:p>
-            <a:pPr indent="0" marL="0">
+            <a:pPr marL="0" indent="0">
               <a:lnSpc>
                 <a:spcPct val="105000"/>
               </a:lnSpc>
@@ -5578,9 +5393,9 @@
                 <a:solidFill>
                   <a:srgbClr val="F8FAFC"/>
                 </a:solidFill>
-                <a:latin typeface="Arial" pitchFamily="34" charset="0"/>
-                <a:ea typeface="Arial" pitchFamily="34" charset="-122"/>
-                <a:cs typeface="Arial" pitchFamily="34" charset="-120"/>
+                <a:latin typeface="Arial" panose="020B0604020202020204" pitchFamily="34" charset="0"/>
+                <a:ea typeface="Arial" panose="020B0604020202020204" pitchFamily="34" charset="-122"/>
+                <a:cs typeface="Arial" panose="020B0604020202020204" pitchFamily="34" charset="-120"/>
               </a:rPr>
               <a:t>Tenant + user-scoped data — students only ever see their own workspace</a:t>
             </a:r>
@@ -5605,7 +5420,6 @@
           <a:solidFill>
             <a:srgbClr val="F59E0B"/>
           </a:solidFill>
-          <a:ln/>
         </p:spPr>
       </p:sp>
       <p:sp>
@@ -5623,13 +5437,12 @@
             <a:avLst/>
           </a:prstGeom>
           <a:noFill/>
-          <a:ln/>
         </p:spPr>
         <p:txBody>
           <a:bodyPr wrap="square" rtlCol="0" anchor="t"/>
           <a:lstStyle/>
           <a:p>
-            <a:pPr indent="0" marL="0">
+            <a:pPr marL="0" indent="0">
               <a:lnSpc>
                 <a:spcPct val="105000"/>
               </a:lnSpc>
@@ -5640,9 +5453,9 @@
                 <a:solidFill>
                   <a:srgbClr val="F8FAFC"/>
                 </a:solidFill>
-                <a:latin typeface="Arial" pitchFamily="34" charset="0"/>
-                <a:ea typeface="Arial" pitchFamily="34" charset="-122"/>
-                <a:cs typeface="Arial" pitchFamily="34" charset="-120"/>
+                <a:latin typeface="Arial" panose="020B0604020202020204" pitchFamily="34" charset="0"/>
+                <a:ea typeface="Arial" panose="020B0604020202020204" pitchFamily="34" charset="-122"/>
+                <a:cs typeface="Arial" panose="020B0604020202020204" pitchFamily="34" charset="-120"/>
               </a:rPr>
               <a:t>Optimistic concurrency — expectedRevision check returns 409 on conflict, never silent overwrite</a:t>
             </a:r>
@@ -5667,7 +5480,6 @@
           <a:solidFill>
             <a:srgbClr val="6366F1"/>
           </a:solidFill>
-          <a:ln/>
         </p:spPr>
       </p:sp>
       <p:sp>
@@ -5685,13 +5497,12 @@
             <a:avLst/>
           </a:prstGeom>
           <a:noFill/>
-          <a:ln/>
         </p:spPr>
         <p:txBody>
           <a:bodyPr wrap="square" rtlCol="0" anchor="t"/>
           <a:lstStyle/>
           <a:p>
-            <a:pPr indent="0" marL="0">
+            <a:pPr marL="0" indent="0">
               <a:lnSpc>
                 <a:spcPct val="105000"/>
               </a:lnSpc>
@@ -5702,9 +5513,9 @@
                 <a:solidFill>
                   <a:srgbClr val="F8FAFC"/>
                 </a:solidFill>
-                <a:latin typeface="Arial" pitchFamily="34" charset="0"/>
-                <a:ea typeface="Arial" pitchFamily="34" charset="-122"/>
-                <a:cs typeface="Arial" pitchFamily="34" charset="-120"/>
+                <a:latin typeface="Arial" panose="020B0604020202020204" pitchFamily="34" charset="0"/>
+                <a:ea typeface="Arial" panose="020B0604020202020204" pitchFamily="34" charset="-122"/>
+                <a:cs typeface="Arial" panose="020B0604020202020204" pitchFamily="34" charset="-120"/>
               </a:rPr>
               <a:t>Smallest-change editing — AI transforms only targeted text, preserves everything else</a:t>
             </a:r>
@@ -5729,7 +5540,6 @@
           <a:solidFill>
             <a:srgbClr val="F59E0B"/>
           </a:solidFill>
-          <a:ln/>
         </p:spPr>
       </p:sp>
       <p:sp>
@@ -5747,13 +5557,12 @@
             <a:avLst/>
           </a:prstGeom>
           <a:noFill/>
-          <a:ln/>
         </p:spPr>
         <p:txBody>
           <a:bodyPr wrap="square" rtlCol="0" anchor="t"/>
           <a:lstStyle/>
           <a:p>
-            <a:pPr indent="0" marL="0">
+            <a:pPr marL="0" indent="0">
               <a:lnSpc>
                 <a:spcPct val="105000"/>
               </a:lnSpc>
@@ -5764,9 +5573,9 @@
                 <a:solidFill>
                   <a:srgbClr val="F8FAFC"/>
                 </a:solidFill>
-                <a:latin typeface="Arial" pitchFamily="34" charset="0"/>
-                <a:ea typeface="Arial" pitchFamily="34" charset="-122"/>
-                <a:cs typeface="Arial" pitchFamily="34" charset="-120"/>
+                <a:latin typeface="Arial" panose="020B0604020202020204" pitchFamily="34" charset="0"/>
+                <a:ea typeface="Arial" panose="020B0604020202020204" pitchFamily="34" charset="-122"/>
+                <a:cs typeface="Arial" panose="020B0604020202020204" pitchFamily="34" charset="-120"/>
               </a:rPr>
               <a:t>Safe highlights — fixed CSS class allowlist; no raw HTML or inline styles accepted</a:t>
             </a:r>
@@ -5791,7 +5600,6 @@
           <a:solidFill>
             <a:srgbClr val="6366F1"/>
           </a:solidFill>
-          <a:ln/>
         </p:spPr>
       </p:sp>
       <p:sp>
@@ -5809,13 +5617,12 @@
             <a:avLst/>
           </a:prstGeom>
           <a:noFill/>
-          <a:ln/>
         </p:spPr>
         <p:txBody>
           <a:bodyPr wrap="square" rtlCol="0" anchor="t"/>
           <a:lstStyle/>
           <a:p>
-            <a:pPr indent="0" marL="0">
+            <a:pPr marL="0" indent="0">
               <a:lnSpc>
                 <a:spcPct val="105000"/>
               </a:lnSpc>
@@ -5826,9 +5633,9 @@
                 <a:solidFill>
                   <a:srgbClr val="F8FAFC"/>
                 </a:solidFill>
-                <a:latin typeface="Arial" pitchFamily="34" charset="0"/>
-                <a:ea typeface="Arial" pitchFamily="34" charset="-122"/>
-                <a:cs typeface="Arial" pitchFamily="34" charset="-120"/>
+                <a:latin typeface="Arial" panose="020B0604020202020204" pitchFamily="34" charset="0"/>
+                <a:ea typeface="Arial" panose="020B0604020202020204" pitchFamily="34" charset="-122"/>
+                <a:cs typeface="Arial" panose="020B0604020202020204" pitchFamily="34" charset="-120"/>
               </a:rPr>
               <a:t>Moderation + encryption — inputs and outputs moderated, message content encrypted</a:t>
             </a:r>
@@ -5853,7 +5660,6 @@
           <a:solidFill>
             <a:srgbClr val="F59E0B"/>
           </a:solidFill>
-          <a:ln/>
         </p:spPr>
       </p:sp>
       <p:sp>
@@ -5871,13 +5677,12 @@
             <a:avLst/>
           </a:prstGeom>
           <a:noFill/>
-          <a:ln/>
         </p:spPr>
         <p:txBody>
           <a:bodyPr wrap="square" rtlCol="0" anchor="t"/>
           <a:lstStyle/>
           <a:p>
-            <a:pPr indent="0" marL="0">
+            <a:pPr marL="0" indent="0">
               <a:lnSpc>
                 <a:spcPct val="105000"/>
               </a:lnSpc>
@@ -5888,9 +5693,9 @@
                 <a:solidFill>
                   <a:srgbClr val="F8FAFC"/>
                 </a:solidFill>
-                <a:latin typeface="Arial" pitchFamily="34" charset="0"/>
-                <a:ea typeface="Arial" pitchFamily="34" charset="-122"/>
-                <a:cs typeface="Arial" pitchFamily="34" charset="-120"/>
+                <a:latin typeface="Arial" panose="020B0604020202020204" pitchFamily="34" charset="0"/>
+                <a:ea typeface="Arial" panose="020B0604020202020204" pitchFamily="34" charset="-122"/>
+                <a:cs typeface="Arial" panose="020B0604020202020204" pitchFamily="34" charset="-120"/>
               </a:rPr>
               <a:t>Cancellation-safe streams — stopping generation can't leave a half-saved document</a:t>
             </a:r>
@@ -5913,13 +5718,12 @@
             <a:avLst/>
           </a:prstGeom>
           <a:noFill/>
-          <a:ln/>
         </p:spPr>
         <p:txBody>
           <a:bodyPr wrap="square" rtlCol="0" anchor="ctr"/>
           <a:lstStyle/>
           <a:p>
-            <a:pPr indent="0" marL="0">
+            <a:pPr marL="0" indent="0">
               <a:buNone/>
             </a:pPr>
             <a:r>
@@ -5927,9 +5731,9 @@
                 <a:solidFill>
                   <a:srgbClr val="94A3B8"/>
                 </a:solidFill>
-                <a:latin typeface="Arial" pitchFamily="34" charset="0"/>
-                <a:ea typeface="Arial" pitchFamily="34" charset="-122"/>
-                <a:cs typeface="Arial" pitchFamily="34" charset="-120"/>
+                <a:latin typeface="Arial" panose="020B0604020202020204" pitchFamily="34" charset="0"/>
+                <a:ea typeface="Arial" panose="020B0604020202020204" pitchFamily="34" charset="-122"/>
+                <a:cs typeface="Arial" panose="020B0604020202020204" pitchFamily="34" charset="-120"/>
               </a:rPr>
               <a:t>StudyNotes+</a:t>
             </a:r>
@@ -5952,13 +5756,12 @@
             <a:avLst/>
           </a:prstGeom>
           <a:noFill/>
-          <a:ln/>
         </p:spPr>
         <p:txBody>
           <a:bodyPr wrap="square" rtlCol="0" anchor="ctr"/>
           <a:lstStyle/>
           <a:p>
-            <a:pPr algn="r" indent="0" marL="0">
+            <a:pPr marL="0" indent="0" algn="r">
               <a:buNone/>
             </a:pPr>
             <a:r>
@@ -5966,9 +5769,9 @@
                 <a:solidFill>
                   <a:srgbClr val="94A3B8"/>
                 </a:solidFill>
-                <a:latin typeface="Arial" pitchFamily="34" charset="0"/>
-                <a:ea typeface="Arial" pitchFamily="34" charset="-122"/>
-                <a:cs typeface="Arial" pitchFamily="34" charset="-120"/>
+                <a:latin typeface="Arial" panose="020B0604020202020204" pitchFamily="34" charset="0"/>
+                <a:ea typeface="Arial" panose="020B0604020202020204" pitchFamily="34" charset="-122"/>
+                <a:cs typeface="Arial" panose="020B0604020202020204" pitchFamily="34" charset="-120"/>
               </a:rPr>
               <a:t>6 / 7</a:t>
             </a:r>
@@ -5986,12 +5789,13 @@
 
 <file path=ppt/slides/slide7.xml><?xml version="1.0" encoding="utf-8"?>
 <p:sld xmlns:a="http://schemas.openxmlformats.org/drawingml/2006/main" xmlns:r="http://schemas.openxmlformats.org/officeDocument/2006/relationships" xmlns:p="http://schemas.openxmlformats.org/presentationml/2006/main">
-  <p:cSld name="Slide 7">
+  <p:cSld>
     <p:bg>
       <p:bgPr>
         <a:solidFill>
           <a:srgbClr val="0B1020"/>
         </a:solidFill>
+        <a:effectLst/>
       </p:bgPr>
     </p:bg>
     <p:spTree>
@@ -6027,7 +5831,6 @@
               <a:alpha val="18000"/>
             </a:srgbClr>
           </a:solidFill>
-          <a:ln/>
         </p:spPr>
       </p:sp>
       <p:sp>
@@ -6049,7 +5852,6 @@
               <a:alpha val="12000"/>
             </a:srgbClr>
           </a:solidFill>
-          <a:ln/>
         </p:spPr>
       </p:sp>
       <p:sp>
@@ -6071,7 +5873,6 @@
               <a:alpha val="10000"/>
             </a:srgbClr>
           </a:solidFill>
-          <a:ln/>
         </p:spPr>
       </p:sp>
       <p:sp>
@@ -6089,13 +5890,12 @@
             <a:avLst/>
           </a:prstGeom>
           <a:noFill/>
-          <a:ln/>
         </p:spPr>
         <p:txBody>
           <a:bodyPr wrap="square" rtlCol="0" anchor="ctr"/>
           <a:lstStyle/>
           <a:p>
-            <a:pPr indent="0" marL="0">
+            <a:pPr marL="0" indent="0">
               <a:buNone/>
             </a:pPr>
             <a:r>
@@ -6103,9 +5903,9 @@
                 <a:solidFill>
                   <a:srgbClr val="F8FAFC"/>
                 </a:solidFill>
-                <a:latin typeface="Arial" pitchFamily="34" charset="0"/>
-                <a:ea typeface="Arial" pitchFamily="34" charset="-122"/>
-                <a:cs typeface="Arial" pitchFamily="34" charset="-120"/>
+                <a:latin typeface="Arial" panose="020B0604020202020204" pitchFamily="34" charset="0"/>
+                <a:ea typeface="Arial" panose="020B0604020202020204" pitchFamily="34" charset="-122"/>
+                <a:cs typeface="Arial" panose="020B0604020202020204" pitchFamily="34" charset="-120"/>
               </a:rPr>
               <a:t>Impact &amp; Future Scope</a:t>
             </a:r>
@@ -6128,13 +5928,12 @@
             <a:avLst/>
           </a:prstGeom>
           <a:noFill/>
-          <a:ln/>
         </p:spPr>
         <p:txBody>
           <a:bodyPr wrap="square" rtlCol="0" anchor="ctr"/>
           <a:lstStyle/>
           <a:p>
-            <a:pPr indent="0" marL="0">
+            <a:pPr marL="0" indent="0">
               <a:buNone/>
             </a:pPr>
             <a:r>
@@ -6142,9 +5941,9 @@
                 <a:solidFill>
                   <a:srgbClr val="94A3B8"/>
                 </a:solidFill>
-                <a:latin typeface="Arial" pitchFamily="34" charset="0"/>
-                <a:ea typeface="Arial" pitchFamily="34" charset="-122"/>
-                <a:cs typeface="Arial" pitchFamily="34" charset="-120"/>
+                <a:latin typeface="Arial" panose="020B0604020202020204" pitchFamily="34" charset="0"/>
+                <a:ea typeface="Arial" panose="020B0604020202020204" pitchFamily="34" charset="-122"/>
+                <a:cs typeface="Arial" panose="020B0604020202020204" pitchFamily="34" charset="-120"/>
               </a:rPr>
               <a:t>An MVP today — a platform for effortless learning + notes tomorrow.</a:t>
             </a:r>
@@ -6171,7 +5970,6 @@
           <a:solidFill>
             <a:srgbClr val="F59E0B"/>
           </a:solidFill>
-          <a:ln/>
         </p:spPr>
       </p:sp>
       <p:sp>
@@ -6216,23 +6014,22 @@
             <a:avLst/>
           </a:prstGeom>
           <a:noFill/>
-          <a:ln/>
         </p:spPr>
         <p:txBody>
           <a:bodyPr wrap="square" rtlCol="0" anchor="ctr"/>
           <a:lstStyle/>
           <a:p>
-            <a:pPr indent="0" marL="0">
-              <a:buNone/>
-            </a:pPr>
-            <a:r>
-              <a:rPr lang="en-US" sz="1400" b="1" spc="100" kern="0" dirty="0">
+            <a:pPr marL="0" indent="0">
+              <a:buNone/>
+            </a:pPr>
+            <a:r>
+              <a:rPr lang="en-US" sz="1400" b="1" kern="0" spc="100" dirty="0">
                 <a:solidFill>
                   <a:srgbClr val="F59E0B"/>
                 </a:solidFill>
-                <a:latin typeface="Arial" pitchFamily="34" charset="0"/>
-                <a:ea typeface="Arial" pitchFamily="34" charset="-122"/>
-                <a:cs typeface="Arial" pitchFamily="34" charset="-120"/>
+                <a:latin typeface="Arial" panose="020B0604020202020204" pitchFamily="34" charset="0"/>
+                <a:ea typeface="Arial" panose="020B0604020202020204" pitchFamily="34" charset="-122"/>
+                <a:cs typeface="Arial" panose="020B0604020202020204" pitchFamily="34" charset="-120"/>
               </a:rPr>
               <a:t>WHY IT MATTERS</a:t>
             </a:r>
@@ -6257,7 +6054,6 @@
           <a:solidFill>
             <a:srgbClr val="6366F1"/>
           </a:solidFill>
-          <a:ln/>
         </p:spPr>
       </p:sp>
       <p:sp>
@@ -6275,13 +6071,12 @@
             <a:avLst/>
           </a:prstGeom>
           <a:noFill/>
-          <a:ln/>
         </p:spPr>
         <p:txBody>
           <a:bodyPr wrap="square" rtlCol="0" anchor="t"/>
           <a:lstStyle/>
           <a:p>
-            <a:pPr indent="0" marL="0">
+            <a:pPr marL="0" indent="0">
               <a:lnSpc>
                 <a:spcPct val="105000"/>
               </a:lnSpc>
@@ -6292,9 +6087,9 @@
                 <a:solidFill>
                   <a:srgbClr val="F8FAFC"/>
                 </a:solidFill>
-                <a:latin typeface="Arial" pitchFamily="34" charset="0"/>
-                <a:ea typeface="Arial" pitchFamily="34" charset="-122"/>
-                <a:cs typeface="Arial" pitchFamily="34" charset="-120"/>
+                <a:latin typeface="Arial" panose="020B0604020202020204" pitchFamily="34" charset="0"/>
+                <a:ea typeface="Arial" panose="020B0604020202020204" pitchFamily="34" charset="-122"/>
+                <a:cs typeface="Arial" panose="020B0604020202020204" pitchFamily="34" charset="-120"/>
               </a:rPr>
               <a:t>Core purpose: a platform where students learn and generate notes at the same time, with zero effort</a:t>
             </a:r>
@@ -6319,7 +6114,6 @@
           <a:solidFill>
             <a:srgbClr val="F59E0B"/>
           </a:solidFill>
-          <a:ln/>
         </p:spPr>
       </p:sp>
       <p:sp>
@@ -6337,13 +6131,12 @@
             <a:avLst/>
           </a:prstGeom>
           <a:noFill/>
-          <a:ln/>
         </p:spPr>
         <p:txBody>
           <a:bodyPr wrap="square" rtlCol="0" anchor="t"/>
           <a:lstStyle/>
           <a:p>
-            <a:pPr indent="0" marL="0">
+            <a:pPr marL="0" indent="0">
               <a:lnSpc>
                 <a:spcPct val="105000"/>
               </a:lnSpc>
@@ -6354,9 +6147,9 @@
                 <a:solidFill>
                   <a:srgbClr val="F8FAFC"/>
                 </a:solidFill>
-                <a:latin typeface="Arial" pitchFamily="34" charset="0"/>
-                <a:ea typeface="Arial" pitchFamily="34" charset="-122"/>
-                <a:cs typeface="Arial" pitchFamily="34" charset="-120"/>
+                <a:latin typeface="Arial" panose="020B0604020202020204" pitchFamily="34" charset="0"/>
+                <a:ea typeface="Arial" panose="020B0604020202020204" pitchFamily="34" charset="-122"/>
+                <a:cs typeface="Arial" panose="020B0604020202020204" pitchFamily="34" charset="-120"/>
               </a:rPr>
               <a:t>Turns a 300-page NCERT book into a personal, owned, versioned revision doc</a:t>
             </a:r>
@@ -6381,7 +6174,6 @@
           <a:solidFill>
             <a:srgbClr val="6366F1"/>
           </a:solidFill>
-          <a:ln/>
         </p:spPr>
       </p:sp>
       <p:sp>
@@ -6399,13 +6191,12 @@
             <a:avLst/>
           </a:prstGeom>
           <a:noFill/>
-          <a:ln/>
         </p:spPr>
         <p:txBody>
           <a:bodyPr wrap="square" rtlCol="0" anchor="t"/>
           <a:lstStyle/>
           <a:p>
-            <a:pPr indent="0" marL="0">
+            <a:pPr marL="0" indent="0">
               <a:lnSpc>
                 <a:spcPct val="105000"/>
               </a:lnSpc>
@@ -6416,9 +6207,9 @@
                 <a:solidFill>
                   <a:srgbClr val="F8FAFC"/>
                 </a:solidFill>
-                <a:latin typeface="Arial" pitchFamily="34" charset="0"/>
-                <a:ea typeface="Arial" pitchFamily="34" charset="-122"/>
-                <a:cs typeface="Arial" pitchFamily="34" charset="-120"/>
+                <a:latin typeface="Arial" panose="020B0604020202020204" pitchFamily="34" charset="0"/>
+                <a:ea typeface="Arial" panose="020B0604020202020204" pitchFamily="34" charset="-122"/>
+                <a:cs typeface="Arial" panose="020B0604020202020204" pitchFamily="34" charset="-120"/>
               </a:rPr>
               <a:t>Students stay on-syllabus (NCERT-only retrieval) with source citations</a:t>
             </a:r>
@@ -6468,23 +6259,22 @@
             <a:avLst/>
           </a:prstGeom>
           <a:noFill/>
-          <a:ln/>
         </p:spPr>
         <p:txBody>
           <a:bodyPr wrap="square" rtlCol="0" anchor="ctr"/>
           <a:lstStyle/>
           <a:p>
-            <a:pPr indent="0" marL="0">
-              <a:buNone/>
-            </a:pPr>
-            <a:r>
-              <a:rPr lang="en-US" sz="1400" b="1" spc="100" kern="0" dirty="0">
+            <a:pPr marL="0" indent="0">
+              <a:buNone/>
+            </a:pPr>
+            <a:r>
+              <a:rPr lang="en-US" sz="1400" b="1" kern="0" spc="100" dirty="0">
                 <a:solidFill>
                   <a:srgbClr val="2DD4BF"/>
                 </a:solidFill>
-                <a:latin typeface="Arial" pitchFamily="34" charset="0"/>
-                <a:ea typeface="Arial" pitchFamily="34" charset="-122"/>
-                <a:cs typeface="Arial" pitchFamily="34" charset="-120"/>
+                <a:latin typeface="Arial" panose="020B0604020202020204" pitchFamily="34" charset="0"/>
+                <a:ea typeface="Arial" panose="020B0604020202020204" pitchFamily="34" charset="-122"/>
+                <a:cs typeface="Arial" panose="020B0604020202020204" pitchFamily="34" charset="-120"/>
               </a:rPr>
               <a:t>FUTURE SCOPE</a:t>
             </a:r>
@@ -6509,7 +6299,6 @@
           <a:solidFill>
             <a:srgbClr val="6366F1"/>
           </a:solidFill>
-          <a:ln/>
         </p:spPr>
       </p:sp>
       <p:sp>
@@ -6527,13 +6316,12 @@
             <a:avLst/>
           </a:prstGeom>
           <a:noFill/>
-          <a:ln/>
         </p:spPr>
         <p:txBody>
           <a:bodyPr wrap="square" rtlCol="0" anchor="t"/>
           <a:lstStyle/>
           <a:p>
-            <a:pPr indent="0" marL="0">
+            <a:pPr marL="0" indent="0">
               <a:lnSpc>
                 <a:spcPct val="105000"/>
               </a:lnSpc>
@@ -6544,9 +6332,9 @@
                 <a:solidFill>
                   <a:srgbClr val="F8FAFC"/>
                 </a:solidFill>
-                <a:latin typeface="Arial" pitchFamily="34" charset="0"/>
-                <a:ea typeface="Arial" pitchFamily="34" charset="-122"/>
-                <a:cs typeface="Arial" pitchFamily="34" charset="-120"/>
+                <a:latin typeface="Arial" panose="020B0604020202020204" pitchFamily="34" charset="0"/>
+                <a:ea typeface="Arial" panose="020B0604020202020204" pitchFamily="34" charset="-122"/>
+                <a:cs typeface="Arial" panose="020B0604020202020204" pitchFamily="34" charset="-120"/>
               </a:rPr>
               <a:t>Any class &amp; subject — not just CBSE Class 10 Maths/Science</a:t>
             </a:r>
@@ -6571,7 +6359,6 @@
           <a:solidFill>
             <a:srgbClr val="F59E0B"/>
           </a:solidFill>
-          <a:ln/>
         </p:spPr>
       </p:sp>
       <p:sp>
@@ -6589,13 +6376,12 @@
             <a:avLst/>
           </a:prstGeom>
           <a:noFill/>
-          <a:ln/>
         </p:spPr>
         <p:txBody>
           <a:bodyPr wrap="square" rtlCol="0" anchor="t"/>
           <a:lstStyle/>
           <a:p>
-            <a:pPr indent="0" marL="0">
+            <a:pPr marL="0" indent="0">
               <a:lnSpc>
                 <a:spcPct val="105000"/>
               </a:lnSpc>
@@ -6606,9 +6392,9 @@
                 <a:solidFill>
                   <a:srgbClr val="F8FAFC"/>
                 </a:solidFill>
-                <a:latin typeface="Arial" pitchFamily="34" charset="0"/>
-                <a:ea typeface="Arial" pitchFamily="34" charset="-122"/>
-                <a:cs typeface="Arial" pitchFamily="34" charset="-120"/>
+                <a:latin typeface="Arial" panose="020B0604020202020204" pitchFamily="34" charset="0"/>
+                <a:ea typeface="Arial" panose="020B0604020202020204" pitchFamily="34" charset="-122"/>
+                <a:cs typeface="Arial" panose="020B0604020202020204" pitchFamily="34" charset="-120"/>
               </a:rPr>
               <a:t>Autonomous AI agent — no need to pick subject, course, or mode</a:t>
             </a:r>
@@ -6633,7 +6419,6 @@
           <a:solidFill>
             <a:srgbClr val="6366F1"/>
           </a:solidFill>
-          <a:ln/>
         </p:spPr>
       </p:sp>
       <p:sp>
@@ -6651,13 +6436,12 @@
             <a:avLst/>
           </a:prstGeom>
           <a:noFill/>
-          <a:ln/>
         </p:spPr>
         <p:txBody>
           <a:bodyPr wrap="square" rtlCol="0" anchor="t"/>
           <a:lstStyle/>
           <a:p>
-            <a:pPr indent="0" marL="0">
+            <a:pPr marL="0" indent="0">
               <a:lnSpc>
                 <a:spcPct val="105000"/>
               </a:lnSpc>
@@ -6668,9 +6452,9 @@
                 <a:solidFill>
                   <a:srgbClr val="F8FAFC"/>
                 </a:solidFill>
-                <a:latin typeface="Arial" pitchFamily="34" charset="0"/>
-                <a:ea typeface="Arial" pitchFamily="34" charset="-122"/>
-                <a:cs typeface="Arial" pitchFamily="34" charset="-120"/>
+                <a:latin typeface="Arial" panose="020B0604020202020204" pitchFamily="34" charset="0"/>
+                <a:ea typeface="Arial" panose="020B0604020202020204" pitchFamily="34" charset="-122"/>
+                <a:cs typeface="Arial" panose="020B0604020202020204" pitchFamily="34" charset="-120"/>
               </a:rPr>
               <a:t>B2B + B2C: schools/institutions and direct-to-student</a:t>
             </a:r>
@@ -6693,13 +6477,12 @@
             <a:avLst/>
           </a:prstGeom>
           <a:noFill/>
-          <a:ln/>
         </p:spPr>
         <p:txBody>
           <a:bodyPr wrap="square" rtlCol="0" anchor="ctr"/>
           <a:lstStyle/>
           <a:p>
-            <a:pPr indent="0" marL="0">
+            <a:pPr marL="0" indent="0">
               <a:buNone/>
             </a:pPr>
             <a:r>
@@ -6707,9 +6490,9 @@
                 <a:solidFill>
                   <a:srgbClr val="94A3B8"/>
                 </a:solidFill>
-                <a:latin typeface="Arial" pitchFamily="34" charset="0"/>
-                <a:ea typeface="Arial" pitchFamily="34" charset="-122"/>
-                <a:cs typeface="Arial" pitchFamily="34" charset="-120"/>
+                <a:latin typeface="Arial" panose="020B0604020202020204" pitchFamily="34" charset="0"/>
+                <a:ea typeface="Arial" panose="020B0604020202020204" pitchFamily="34" charset="-122"/>
+                <a:cs typeface="Arial" panose="020B0604020202020204" pitchFamily="34" charset="-120"/>
               </a:rPr>
               <a:t>StudyNotes+</a:t>
             </a:r>
@@ -6732,13 +6515,12 @@
             <a:avLst/>
           </a:prstGeom>
           <a:noFill/>
-          <a:ln/>
         </p:spPr>
         <p:txBody>
           <a:bodyPr wrap="square" rtlCol="0" anchor="ctr"/>
           <a:lstStyle/>
           <a:p>
-            <a:pPr algn="r" indent="0" marL="0">
+            <a:pPr marL="0" indent="0" algn="r">
               <a:buNone/>
             </a:pPr>
             <a:r>
@@ -6746,9 +6528,9 @@
                 <a:solidFill>
                   <a:srgbClr val="94A3B8"/>
                 </a:solidFill>
-                <a:latin typeface="Arial" pitchFamily="34" charset="0"/>
-                <a:ea typeface="Arial" pitchFamily="34" charset="-122"/>
-                <a:cs typeface="Arial" pitchFamily="34" charset="-120"/>
+                <a:latin typeface="Arial" panose="020B0604020202020204" pitchFamily="34" charset="0"/>
+                <a:ea typeface="Arial" panose="020B0604020202020204" pitchFamily="34" charset="-122"/>
+                <a:cs typeface="Arial" panose="020B0604020202020204" pitchFamily="34" charset="-120"/>
               </a:rPr>
               <a:t>7 / 7</a:t>
             </a:r>
@@ -6766,12 +6548,13 @@
 
 <file path=ppt/slides/slide8.xml><?xml version="1.0" encoding="utf-8"?>
 <p:sld xmlns:a="http://schemas.openxmlformats.org/drawingml/2006/main" xmlns:r="http://schemas.openxmlformats.org/officeDocument/2006/relationships" xmlns:p="http://schemas.openxmlformats.org/presentationml/2006/main">
-  <p:cSld name="Slide 8">
+  <p:cSld>
     <p:bg>
       <p:bgPr>
         <a:solidFill>
           <a:srgbClr val="0B1020"/>
         </a:solidFill>
+        <a:effectLst/>
       </p:bgPr>
     </p:bg>
     <p:spTree>
@@ -6807,7 +6590,6 @@
               <a:alpha val="18000"/>
             </a:srgbClr>
           </a:solidFill>
-          <a:ln/>
         </p:spPr>
       </p:sp>
       <p:sp>
@@ -6829,7 +6611,6 @@
               <a:alpha val="12000"/>
             </a:srgbClr>
           </a:solidFill>
-          <a:ln/>
         </p:spPr>
       </p:sp>
       <p:sp>
@@ -6851,7 +6632,6 @@
               <a:alpha val="10000"/>
             </a:srgbClr>
           </a:solidFill>
-          <a:ln/>
         </p:spPr>
       </p:sp>
       <p:sp>
@@ -6869,13 +6649,12 @@
             <a:avLst/>
           </a:prstGeom>
           <a:noFill/>
-          <a:ln/>
         </p:spPr>
         <p:txBody>
           <a:bodyPr wrap="square" rtlCol="0" anchor="ctr"/>
           <a:lstStyle/>
           <a:p>
-            <a:pPr indent="0" marL="0">
+            <a:pPr marL="0" indent="0">
               <a:buNone/>
             </a:pPr>
             <a:r>
@@ -6883,9 +6662,9 @@
                 <a:solidFill>
                   <a:srgbClr val="F8FAFC"/>
                 </a:solidFill>
-                <a:latin typeface="Arial" pitchFamily="34" charset="0"/>
-                <a:ea typeface="Arial" pitchFamily="34" charset="-122"/>
-                <a:cs typeface="Arial" pitchFamily="34" charset="-120"/>
+                <a:latin typeface="Arial" panose="020B0604020202020204" pitchFamily="34" charset="0"/>
+                <a:ea typeface="Arial" panose="020B0604020202020204" pitchFamily="34" charset="-122"/>
+                <a:cs typeface="Arial" panose="020B0604020202020204" pitchFamily="34" charset="-120"/>
               </a:rPr>
               <a:t>Appendix — For the Judges</a:t>
             </a:r>
@@ -6908,13 +6687,12 @@
             <a:avLst/>
           </a:prstGeom>
           <a:noFill/>
-          <a:ln/>
         </p:spPr>
         <p:txBody>
           <a:bodyPr wrap="square" rtlCol="0" anchor="ctr"/>
           <a:lstStyle/>
           <a:p>
-            <a:pPr indent="0" marL="0">
+            <a:pPr marL="0" indent="0">
               <a:buNone/>
             </a:pPr>
             <a:r>
@@ -6922,9 +6700,9 @@
                 <a:solidFill>
                   <a:srgbClr val="94A3B8"/>
                 </a:solidFill>
-                <a:latin typeface="Arial" pitchFamily="34" charset="0"/>
-                <a:ea typeface="Arial" pitchFamily="34" charset="-122"/>
-                <a:cs typeface="Arial" pitchFamily="34" charset="-120"/>
+                <a:latin typeface="Arial" panose="020B0604020202020204" pitchFamily="34" charset="0"/>
+                <a:ea typeface="Arial" panose="020B0604020202020204" pitchFamily="34" charset="-122"/>
+                <a:cs typeface="Arial" panose="020B0604020202020204" pitchFamily="34" charset="-120"/>
               </a:rPr>
               <a:t>Deep-dive facts if asked.</a:t>
             </a:r>
@@ -6951,7 +6729,6 @@
           <a:solidFill>
             <a:srgbClr val="F59E0B"/>
           </a:solidFill>
-          <a:ln/>
         </p:spPr>
       </p:sp>
       <p:sp>
@@ -6971,7 +6748,6 @@
           <a:solidFill>
             <a:srgbClr val="6366F1"/>
           </a:solidFill>
-          <a:ln/>
         </p:spPr>
       </p:sp>
       <p:sp>
@@ -6989,13 +6765,12 @@
             <a:avLst/>
           </a:prstGeom>
           <a:noFill/>
-          <a:ln/>
         </p:spPr>
         <p:txBody>
           <a:bodyPr wrap="square" rtlCol="0" anchor="t"/>
           <a:lstStyle/>
           <a:p>
-            <a:pPr indent="0" marL="0">
+            <a:pPr marL="0" indent="0">
               <a:lnSpc>
                 <a:spcPct val="105000"/>
               </a:lnSpc>
@@ -7006,9 +6781,9 @@
                 <a:solidFill>
                   <a:srgbClr val="F8FAFC"/>
                 </a:solidFill>
-                <a:latin typeface="Arial" pitchFamily="34" charset="0"/>
-                <a:ea typeface="Arial" pitchFamily="34" charset="-122"/>
-                <a:cs typeface="Arial" pitchFamily="34" charset="-120"/>
+                <a:latin typeface="Arial" panose="020B0604020202020204" pitchFamily="34" charset="0"/>
+                <a:ea typeface="Arial" panose="020B0604020202020204" pitchFamily="34" charset="-122"/>
+                <a:cs typeface="Arial" panose="020B0604020202020204" pitchFamily="34" charset="-120"/>
               </a:rPr>
               <a:t>Data model: user_note_documents (one per student+chapter) with user_note_document_versions archive; uniqueness (tenant_id, user_id, subject, chapter_number, language)</a:t>
             </a:r>
@@ -7033,7 +6808,6 @@
           <a:solidFill>
             <a:srgbClr val="F59E0B"/>
           </a:solidFill>
-          <a:ln/>
         </p:spPr>
       </p:sp>
       <p:sp>
@@ -7051,13 +6825,12 @@
             <a:avLst/>
           </a:prstGeom>
           <a:noFill/>
-          <a:ln/>
         </p:spPr>
         <p:txBody>
           <a:bodyPr wrap="square" rtlCol="0" anchor="t"/>
           <a:lstStyle/>
           <a:p>
-            <a:pPr indent="0" marL="0">
+            <a:pPr marL="0" indent="0">
               <a:lnSpc>
                 <a:spcPct val="105000"/>
               </a:lnSpc>
@@ -7068,9 +6841,9 @@
                 <a:solidFill>
                   <a:srgbClr val="F8FAFC"/>
                 </a:solidFill>
-                <a:latin typeface="Arial" pitchFamily="34" charset="0"/>
-                <a:ea typeface="Arial" pitchFamily="34" charset="-122"/>
-                <a:cs typeface="Arial" pitchFamily="34" charset="-120"/>
+                <a:latin typeface="Arial" panose="020B0604020202020204" pitchFamily="34" charset="0"/>
+                <a:ea typeface="Arial" panose="020B0604020202020204" pitchFamily="34" charset="-122"/>
+                <a:cs typeface="Arial" panose="020B0604020202020204" pitchFamily="34" charset="-120"/>
               </a:rPr>
               <a:t>API: POST/GET/PATCH /api/note-documents, POST .../commands, POST .../undo; legacy /api/notes returns 410 Gone</a:t>
             </a:r>
@@ -7095,7 +6868,6 @@
           <a:solidFill>
             <a:srgbClr val="6366F1"/>
           </a:solidFill>
-          <a:ln/>
         </p:spPr>
       </p:sp>
       <p:sp>
@@ -7113,13 +6885,12 @@
             <a:avLst/>
           </a:prstGeom>
           <a:noFill/>
-          <a:ln/>
         </p:spPr>
         <p:txBody>
           <a:bodyPr wrap="square" rtlCol="0" anchor="t"/>
           <a:lstStyle/>
           <a:p>
-            <a:pPr indent="0" marL="0">
+            <a:pPr marL="0" indent="0">
               <a:lnSpc>
                 <a:spcPct val="105000"/>
               </a:lnSpc>
@@ -7130,9 +6901,9 @@
                 <a:solidFill>
                   <a:srgbClr val="F8FAFC"/>
                 </a:solidFill>
-                <a:latin typeface="Arial" pitchFamily="34" charset="0"/>
-                <a:ea typeface="Arial" pitchFamily="34" charset="-122"/>
-                <a:cs typeface="Arial" pitchFamily="34" charset="-120"/>
+                <a:latin typeface="Arial" panose="020B0604020202020204" pitchFamily="34" charset="0"/>
+                <a:ea typeface="Arial" panose="020B0604020202020204" pitchFamily="34" charset="-122"/>
+                <a:cs typeface="Arial" panose="020B0604020202020204" pitchFamily="34" charset="-120"/>
               </a:rPr>
               <a:t>Stream event { type: 'note_document_saved', documentId, revision, operation, citations } — client treats doc as saved only after this, not after transport 'done'</a:t>
             </a:r>
@@ -7157,7 +6928,6 @@
           <a:solidFill>
             <a:srgbClr val="F59E0B"/>
           </a:solidFill>
-          <a:ln/>
         </p:spPr>
       </p:sp>
       <p:sp>
@@ -7175,13 +6945,12 @@
             <a:avLst/>
           </a:prstGeom>
           <a:noFill/>
-          <a:ln/>
         </p:spPr>
         <p:txBody>
           <a:bodyPr wrap="square" rtlCol="0" anchor="t"/>
           <a:lstStyle/>
           <a:p>
-            <a:pPr indent="0" marL="0">
+            <a:pPr marL="0" indent="0">
               <a:lnSpc>
                 <a:spcPct val="105000"/>
               </a:lnSpc>
@@ -7192,9 +6961,9 @@
                 <a:solidFill>
                   <a:srgbClr val="F8FAFC"/>
                 </a:solidFill>
-                <a:latin typeface="Arial" pitchFamily="34" charset="0"/>
-                <a:ea typeface="Arial" pitchFamily="34" charset="-122"/>
-                <a:cs typeface="Arial" pitchFamily="34" charset="-120"/>
+                <a:latin typeface="Arial" panose="020B0604020202020204" pitchFamily="34" charset="0"/>
+                <a:ea typeface="Arial" panose="020B0604020202020204" pitchFamily="34" charset="-122"/>
+                <a:cs typeface="Arial" panose="020B0604020202020204" pitchFamily="34" charset="-120"/>
               </a:rPr>
               <a:t>Quality gates: tsc --noEmit, eslint, vitest (18 tests: ownership, tenant boundary, concurrency, command classification, prompt injection)</a:t>
             </a:r>
@@ -7219,7 +6988,6 @@
           <a:solidFill>
             <a:srgbClr val="6366F1"/>
           </a:solidFill>
-          <a:ln/>
         </p:spPr>
       </p:sp>
       <p:sp>
@@ -7237,13 +7005,12 @@
             <a:avLst/>
           </a:prstGeom>
           <a:noFill/>
-          <a:ln/>
         </p:spPr>
         <p:txBody>
           <a:bodyPr wrap="square" rtlCol="0" anchor="t"/>
           <a:lstStyle/>
           <a:p>
-            <a:pPr indent="0" marL="0">
+            <a:pPr marL="0" indent="0">
               <a:lnSpc>
                 <a:spcPct val="105000"/>
               </a:lnSpc>
@@ -7254,9 +7021,9 @@
                 <a:solidFill>
                   <a:srgbClr val="F8FAFC"/>
                 </a:solidFill>
-                <a:latin typeface="Arial" pitchFamily="34" charset="0"/>
-                <a:ea typeface="Arial" pitchFamily="34" charset="-122"/>
-                <a:cs typeface="Arial" pitchFamily="34" charset="-120"/>
+                <a:latin typeface="Arial" panose="020B0604020202020204" pitchFamily="34" charset="0"/>
+                <a:ea typeface="Arial" panose="020B0604020202020204" pitchFamily="34" charset="-122"/>
+                <a:cs typeface="Arial" panose="020B0604020202020204" pitchFamily="34" charset="-120"/>
               </a:rPr>
               <a:t>Limits: notes ≤ 24,000 chars, instructions ≤ 1,000 chars; inputs/outputs moderated</a:t>
             </a:r>
@@ -7279,13 +7046,12 @@
             <a:avLst/>
           </a:prstGeom>
           <a:noFill/>
-          <a:ln/>
         </p:spPr>
         <p:txBody>
           <a:bodyPr wrap="square" rtlCol="0" anchor="ctr"/>
           <a:lstStyle/>
           <a:p>
-            <a:pPr indent="0" marL="0">
+            <a:pPr marL="0" indent="0">
               <a:buNone/>
             </a:pPr>
             <a:r>
@@ -7293,9 +7059,9 @@
                 <a:solidFill>
                   <a:srgbClr val="94A3B8"/>
                 </a:solidFill>
-                <a:latin typeface="Arial" pitchFamily="34" charset="0"/>
-                <a:ea typeface="Arial" pitchFamily="34" charset="-122"/>
-                <a:cs typeface="Arial" pitchFamily="34" charset="-120"/>
+                <a:latin typeface="Arial" panose="020B0604020202020204" pitchFamily="34" charset="0"/>
+                <a:ea typeface="Arial" panose="020B0604020202020204" pitchFamily="34" charset="-122"/>
+                <a:cs typeface="Arial" panose="020B0604020202020204" pitchFamily="34" charset="-120"/>
               </a:rPr>
               <a:t>StudyNotes+</a:t>
             </a:r>
@@ -7318,13 +7084,12 @@
             <a:avLst/>
           </a:prstGeom>
           <a:noFill/>
-          <a:ln/>
         </p:spPr>
         <p:txBody>
           <a:bodyPr wrap="square" rtlCol="0" anchor="ctr"/>
           <a:lstStyle/>
           <a:p>
-            <a:pPr algn="r" indent="0" marL="0">
+            <a:pPr marL="0" indent="0" algn="r">
               <a:buNone/>
             </a:pPr>
             <a:r>
@@ -7332,9 +7097,9 @@
                 <a:solidFill>
                   <a:srgbClr val="94A3B8"/>
                 </a:solidFill>
-                <a:latin typeface="Arial" pitchFamily="34" charset="0"/>
-                <a:ea typeface="Arial" pitchFamily="34" charset="-122"/>
-                <a:cs typeface="Arial" pitchFamily="34" charset="-120"/>
+                <a:latin typeface="Arial" panose="020B0604020202020204" pitchFamily="34" charset="0"/>
+                <a:ea typeface="Arial" panose="020B0604020202020204" pitchFamily="34" charset="-122"/>
+                <a:cs typeface="Arial" panose="020B0604020202020204" pitchFamily="34" charset="-120"/>
               </a:rPr>
               <a:t>7 / 7</a:t>
             </a:r>
@@ -7393,7 +7158,7 @@
     </a:clrScheme>
     <a:fontScheme name="Office">
       <a:majorFont>
-        <a:latin typeface="Calibri Light" panose="020F0302020204030204"/>
+        <a:latin typeface="Calibri Light"/>
         <a:ea typeface=""/>
         <a:cs typeface=""/>
         <a:font script="Jpan" typeface="游ゴシック Light"/>
@@ -7426,26 +7191,9 @@
         <a:font script="Viet" typeface="Times New Roman"/>
         <a:font script="Uigh" typeface="Microsoft Uighur"/>
         <a:font script="Geor" typeface="Sylfaen"/>
-        <a:font script="Armn" typeface="Arial"/>
-        <a:font script="Bugi" typeface="Leelawadee UI"/>
-        <a:font script="Bopo" typeface="Microsoft JhengHei"/>
-        <a:font script="Java" typeface="Javanese Text"/>
-        <a:font script="Lisu" typeface="Segoe UI"/>
-        <a:font script="Mymr" typeface="Myanmar Text"/>
-        <a:font script="Nkoo" typeface="Ebrima"/>
-        <a:font script="Olck" typeface="Nirmala UI"/>
-        <a:font script="Osma" typeface="Ebrima"/>
-        <a:font script="Phag" typeface="Phagspa"/>
-        <a:font script="Syrn" typeface="Estrangelo Edessa"/>
-        <a:font script="Syrj" typeface="Estrangelo Edessa"/>
-        <a:font script="Syre" typeface="Estrangelo Edessa"/>
-        <a:font script="Sora" typeface="Nirmala UI"/>
-        <a:font script="Tale" typeface="Microsoft Tai Le"/>
-        <a:font script="Talu" typeface="Microsoft New Tai Lue"/>
-        <a:font script="Tfng" typeface="Ebrima"/>
       </a:majorFont>
       <a:minorFont>
-        <a:latin typeface="Calibri" panose="020F0502020204030204"/>
+        <a:latin typeface="Calibri"/>
         <a:ea typeface=""/>
         <a:cs typeface=""/>
         <a:font script="Jpan" typeface="游ゴシック"/>
@@ -7478,23 +7226,6 @@
         <a:font script="Viet" typeface="Arial"/>
         <a:font script="Uigh" typeface="Microsoft Uighur"/>
         <a:font script="Geor" typeface="Sylfaen"/>
-        <a:font script="Armn" typeface="Arial"/>
-        <a:font script="Bugi" typeface="Leelawadee UI"/>
-        <a:font script="Bopo" typeface="Microsoft JhengHei"/>
-        <a:font script="Java" typeface="Javanese Text"/>
-        <a:font script="Lisu" typeface="Segoe UI"/>
-        <a:font script="Mymr" typeface="Myanmar Text"/>
-        <a:font script="Nkoo" typeface="Ebrima"/>
-        <a:font script="Olck" typeface="Nirmala UI"/>
-        <a:font script="Osma" typeface="Ebrima"/>
-        <a:font script="Phag" typeface="Phagspa"/>
-        <a:font script="Syrn" typeface="Estrangelo Edessa"/>
-        <a:font script="Syrj" typeface="Estrangelo Edessa"/>
-        <a:font script="Syre" typeface="Estrangelo Edessa"/>
-        <a:font script="Sora" typeface="Nirmala UI"/>
-        <a:font script="Tale" typeface="Microsoft Tai Le"/>
-        <a:font script="Talu" typeface="Microsoft New Tai Lue"/>
-        <a:font script="Tfng" typeface="Ebrima"/>
       </a:minorFont>
     </a:fontScheme>
     <a:fmtScheme name="Office">
@@ -7635,8 +7366,265 @@
       </a:bgFillStyleLst>
     </a:fmtScheme>
   </a:themeElements>
-  <a:objectDefaults/>
-  <a:extraClrSchemeLst/>
+  <a:extLst>
+    <a:ext uri="{05A4C25C-085E-4340-85A3-A5531E510DB2}">
+      <thm15:themeFamily xmlns:thm15="http://schemas.microsoft.com/office/thememl/2012/main" name="Office Theme" id="{62F939B6-93AF-4DB8-9C6B-D6C7DFDC589F}" vid="{4A3C46E8-61CC-4603-A589-7422A47A8E4A}"/>
+    </a:ext>
+  </a:extLst>
+</a:theme>
+</file>
+
+<file path=ppt/theme/theme2.xml><?xml version="1.0" encoding="utf-8"?>
+<a:theme xmlns:a="http://schemas.openxmlformats.org/drawingml/2006/main" name="Office Theme">
+  <a:themeElements>
+    <a:clrScheme name="Office">
+      <a:dk1>
+        <a:sysClr val="windowText" lastClr="000000"/>
+      </a:dk1>
+      <a:lt1>
+        <a:sysClr val="window" lastClr="FFFFFF"/>
+      </a:lt1>
+      <a:dk2>
+        <a:srgbClr val="44546A"/>
+      </a:dk2>
+      <a:lt2>
+        <a:srgbClr val="E7E6E6"/>
+      </a:lt2>
+      <a:accent1>
+        <a:srgbClr val="4472C4"/>
+      </a:accent1>
+      <a:accent2>
+        <a:srgbClr val="ED7D31"/>
+      </a:accent2>
+      <a:accent3>
+        <a:srgbClr val="A5A5A5"/>
+      </a:accent3>
+      <a:accent4>
+        <a:srgbClr val="FFC000"/>
+      </a:accent4>
+      <a:accent5>
+        <a:srgbClr val="5B9BD5"/>
+      </a:accent5>
+      <a:accent6>
+        <a:srgbClr val="70AD47"/>
+      </a:accent6>
+      <a:hlink>
+        <a:srgbClr val="0563C1"/>
+      </a:hlink>
+      <a:folHlink>
+        <a:srgbClr val="954F72"/>
+      </a:folHlink>
+    </a:clrScheme>
+    <a:fontScheme name="Office">
+      <a:majorFont>
+        <a:latin typeface="Calibri Light"/>
+        <a:ea typeface=""/>
+        <a:cs typeface=""/>
+        <a:font script="Jpan" typeface="游ゴシック Light"/>
+        <a:font script="Hang" typeface="맑은 고딕"/>
+        <a:font script="Hans" typeface="等线 Light"/>
+        <a:font script="Hant" typeface="新細明體"/>
+        <a:font script="Arab" typeface="Times New Roman"/>
+        <a:font script="Hebr" typeface="Times New Roman"/>
+        <a:font script="Thai" typeface="Angsana New"/>
+        <a:font script="Ethi" typeface="Nyala"/>
+        <a:font script="Beng" typeface="Vrinda"/>
+        <a:font script="Gujr" typeface="Shruti"/>
+        <a:font script="Khmr" typeface="MoolBoran"/>
+        <a:font script="Knda" typeface="Tunga"/>
+        <a:font script="Guru" typeface="Raavi"/>
+        <a:font script="Cans" typeface="Euphemia"/>
+        <a:font script="Cher" typeface="Plantagenet Cherokee"/>
+        <a:font script="Yiii" typeface="Microsoft Yi Baiti"/>
+        <a:font script="Tibt" typeface="Microsoft Himalaya"/>
+        <a:font script="Thaa" typeface="MV Boli"/>
+        <a:font script="Deva" typeface="Mangal"/>
+        <a:font script="Telu" typeface="Gautami"/>
+        <a:font script="Taml" typeface="Latha"/>
+        <a:font script="Syrc" typeface="Estrangelo Edessa"/>
+        <a:font script="Orya" typeface="Kalinga"/>
+        <a:font script="Mlym" typeface="Kartika"/>
+        <a:font script="Laoo" typeface="DokChampa"/>
+        <a:font script="Sinh" typeface="Iskoola Pota"/>
+        <a:font script="Mong" typeface="Mongolian Baiti"/>
+        <a:font script="Viet" typeface="Times New Roman"/>
+        <a:font script="Uigh" typeface="Microsoft Uighur"/>
+        <a:font script="Geor" typeface="Sylfaen"/>
+      </a:majorFont>
+      <a:minorFont>
+        <a:latin typeface="Calibri"/>
+        <a:ea typeface=""/>
+        <a:cs typeface=""/>
+        <a:font script="Jpan" typeface="游ゴシック"/>
+        <a:font script="Hang" typeface="맑은 고딕"/>
+        <a:font script="Hans" typeface="等线"/>
+        <a:font script="Hant" typeface="新細明體"/>
+        <a:font script="Arab" typeface="Arial"/>
+        <a:font script="Hebr" typeface="Arial"/>
+        <a:font script="Thai" typeface="Cordia New"/>
+        <a:font script="Ethi" typeface="Nyala"/>
+        <a:font script="Beng" typeface="Vrinda"/>
+        <a:font script="Gujr" typeface="Shruti"/>
+        <a:font script="Khmr" typeface="DaunPenh"/>
+        <a:font script="Knda" typeface="Tunga"/>
+        <a:font script="Guru" typeface="Raavi"/>
+        <a:font script="Cans" typeface="Euphemia"/>
+        <a:font script="Cher" typeface="Plantagenet Cherokee"/>
+        <a:font script="Yiii" typeface="Microsoft Yi Baiti"/>
+        <a:font script="Tibt" typeface="Microsoft Himalaya"/>
+        <a:font script="Thaa" typeface="MV Boli"/>
+        <a:font script="Deva" typeface="Mangal"/>
+        <a:font script="Telu" typeface="Gautami"/>
+        <a:font script="Taml" typeface="Latha"/>
+        <a:font script="Syrc" typeface="Estrangelo Edessa"/>
+        <a:font script="Orya" typeface="Kalinga"/>
+        <a:font script="Mlym" typeface="Kartika"/>
+        <a:font script="Laoo" typeface="DokChampa"/>
+        <a:font script="Sinh" typeface="Iskoola Pota"/>
+        <a:font script="Mong" typeface="Mongolian Baiti"/>
+        <a:font script="Viet" typeface="Arial"/>
+        <a:font script="Uigh" typeface="Microsoft Uighur"/>
+        <a:font script="Geor" typeface="Sylfaen"/>
+      </a:minorFont>
+    </a:fontScheme>
+    <a:fmtScheme name="Office">
+      <a:fillStyleLst>
+        <a:solidFill>
+          <a:schemeClr val="phClr"/>
+        </a:solidFill>
+        <a:gradFill rotWithShape="1">
+          <a:gsLst>
+            <a:gs pos="0">
+              <a:schemeClr val="phClr">
+                <a:lumMod val="110000"/>
+                <a:satMod val="105000"/>
+                <a:tint val="67000"/>
+              </a:schemeClr>
+            </a:gs>
+            <a:gs pos="50000">
+              <a:schemeClr val="phClr">
+                <a:lumMod val="105000"/>
+                <a:satMod val="103000"/>
+                <a:tint val="73000"/>
+              </a:schemeClr>
+            </a:gs>
+            <a:gs pos="100000">
+              <a:schemeClr val="phClr">
+                <a:lumMod val="105000"/>
+                <a:satMod val="109000"/>
+                <a:tint val="81000"/>
+              </a:schemeClr>
+            </a:gs>
+          </a:gsLst>
+          <a:lin ang="5400000" scaled="0"/>
+        </a:gradFill>
+        <a:gradFill rotWithShape="1">
+          <a:gsLst>
+            <a:gs pos="0">
+              <a:schemeClr val="phClr">
+                <a:satMod val="103000"/>
+                <a:lumMod val="102000"/>
+                <a:tint val="94000"/>
+              </a:schemeClr>
+            </a:gs>
+            <a:gs pos="50000">
+              <a:schemeClr val="phClr">
+                <a:satMod val="110000"/>
+                <a:lumMod val="100000"/>
+                <a:shade val="100000"/>
+              </a:schemeClr>
+            </a:gs>
+            <a:gs pos="100000">
+              <a:schemeClr val="phClr">
+                <a:lumMod val="99000"/>
+                <a:satMod val="120000"/>
+                <a:shade val="78000"/>
+              </a:schemeClr>
+            </a:gs>
+          </a:gsLst>
+          <a:lin ang="5400000" scaled="0"/>
+        </a:gradFill>
+      </a:fillStyleLst>
+      <a:lnStyleLst>
+        <a:ln w="6350" cap="flat" cmpd="sng" algn="ctr">
+          <a:solidFill>
+            <a:schemeClr val="phClr"/>
+          </a:solidFill>
+          <a:prstDash val="solid"/>
+          <a:miter lim="800000"/>
+        </a:ln>
+        <a:ln w="12700" cap="flat" cmpd="sng" algn="ctr">
+          <a:solidFill>
+            <a:schemeClr val="phClr"/>
+          </a:solidFill>
+          <a:prstDash val="solid"/>
+          <a:miter lim="800000"/>
+        </a:ln>
+        <a:ln w="19050" cap="flat" cmpd="sng" algn="ctr">
+          <a:solidFill>
+            <a:schemeClr val="phClr"/>
+          </a:solidFill>
+          <a:prstDash val="solid"/>
+          <a:miter lim="800000"/>
+        </a:ln>
+      </a:lnStyleLst>
+      <a:effectStyleLst>
+        <a:effectStyle>
+          <a:effectLst/>
+        </a:effectStyle>
+        <a:effectStyle>
+          <a:effectLst/>
+        </a:effectStyle>
+        <a:effectStyle>
+          <a:effectLst>
+            <a:outerShdw blurRad="57150" dist="19050" dir="5400000" algn="ctr" rotWithShape="0">
+              <a:srgbClr val="000000">
+                <a:alpha val="63000"/>
+              </a:srgbClr>
+            </a:outerShdw>
+          </a:effectLst>
+        </a:effectStyle>
+      </a:effectStyleLst>
+      <a:bgFillStyleLst>
+        <a:solidFill>
+          <a:schemeClr val="phClr"/>
+        </a:solidFill>
+        <a:solidFill>
+          <a:schemeClr val="phClr">
+            <a:tint val="95000"/>
+            <a:satMod val="170000"/>
+          </a:schemeClr>
+        </a:solidFill>
+        <a:gradFill rotWithShape="1">
+          <a:gsLst>
+            <a:gs pos="0">
+              <a:schemeClr val="phClr">
+                <a:tint val="93000"/>
+                <a:satMod val="150000"/>
+                <a:shade val="98000"/>
+                <a:lumMod val="102000"/>
+              </a:schemeClr>
+            </a:gs>
+            <a:gs pos="50000">
+              <a:schemeClr val="phClr">
+                <a:tint val="98000"/>
+                <a:satMod val="130000"/>
+                <a:shade val="90000"/>
+                <a:lumMod val="103000"/>
+              </a:schemeClr>
+            </a:gs>
+            <a:gs pos="100000">
+              <a:schemeClr val="phClr">
+                <a:shade val="63000"/>
+                <a:satMod val="120000"/>
+              </a:schemeClr>
+            </a:gs>
+          </a:gsLst>
+          <a:lin ang="5400000" scaled="0"/>
+        </a:gradFill>
+      </a:bgFillStyleLst>
+    </a:fmtScheme>
+  </a:themeElements>
   <a:extLst>
     <a:ext uri="{05A4C25C-085E-4340-85A3-A5531E510DB2}">
       <thm15:themeFamily xmlns:thm15="http://schemas.microsoft.com/office/thememl/2012/main" name="Office Theme" id="{62F939B6-93AF-4DB8-9C6B-D6C7DFDC589F}" vid="{4A3C46E8-61CC-4603-A589-7422A47A8E4A}"/>

</xml_diff>